<commit_message>
Add Play pulse script and strengthen evidence
</commit_message>
<xml_diff>
--- a/MoveInSync_FDE_Case_Study_Presentation.pptx
+++ b/MoveInSync_FDE_Case_Study_Presentation.pptx
@@ -2,17 +2,18 @@
 <file path=ppt/presentation.xml><?xml version="1.0" encoding="utf-8"?>
 <p:presentation xmlns:p="http://schemas.openxmlformats.org/presentationml/2006/main">
   <p:sldMasterIdLst>
-    <p:sldMasterId xmlns:r="http://schemas.openxmlformats.org/officeDocument/2006/relationships" id="2147483648" r:id="Reaf32c09ded74bd4"/>
+    <p:sldMasterId xmlns:r="http://schemas.openxmlformats.org/officeDocument/2006/relationships" id="2147483648" r:id="Ra5efc82727f5461c"/>
   </p:sldMasterIdLst>
   <p:notesMasterIdLst>
-    <p:notesMasterId xmlns:r="http://schemas.openxmlformats.org/officeDocument/2006/relationships" r:id="R06886776ab2c4f14"/>
+    <p:notesMasterId xmlns:r="http://schemas.openxmlformats.org/officeDocument/2006/relationships" r:id="R978350251fe140ee"/>
   </p:notesMasterIdLst>
   <p:sldIdLst>
-    <p:sldId xmlns:r="http://schemas.openxmlformats.org/officeDocument/2006/relationships" id="256" r:id="R59c97aa87e9e419f"/>
-    <p:sldId xmlns:r="http://schemas.openxmlformats.org/officeDocument/2006/relationships" id="257" r:id="R5e1af6e1665a41c0"/>
-    <p:sldId xmlns:r="http://schemas.openxmlformats.org/officeDocument/2006/relationships" id="258" r:id="Rf2ec72abe6954ac1"/>
-    <p:sldId xmlns:r="http://schemas.openxmlformats.org/officeDocument/2006/relationships" id="259" r:id="Ra71f6a92d2884a41"/>
-    <p:sldId xmlns:r="http://schemas.openxmlformats.org/officeDocument/2006/relationships" id="260" r:id="R6d76f141cd2c4a37"/>
+    <p:sldId xmlns:r="http://schemas.openxmlformats.org/officeDocument/2006/relationships" id="256" r:id="Rf2da30c14bf34f09"/>
+    <p:sldId xmlns:r="http://schemas.openxmlformats.org/officeDocument/2006/relationships" id="257" r:id="R8c51cd10e346448e"/>
+    <p:sldId xmlns:r="http://schemas.openxmlformats.org/officeDocument/2006/relationships" id="258" r:id="Rb0e636ba26e94697"/>
+    <p:sldId xmlns:r="http://schemas.openxmlformats.org/officeDocument/2006/relationships" id="259" r:id="Re87d79cc0daf45f7"/>
+    <p:sldId xmlns:r="http://schemas.openxmlformats.org/officeDocument/2006/relationships" id="260" r:id="Rf559b87cb2e34113"/>
+    <p:sldId xmlns:r="http://schemas.openxmlformats.org/officeDocument/2006/relationships" id="261" r:id="R38a9353eb10542af"/>
   </p:sldIdLst>
   <p:sldSz cx="12192000" cy="6858000"/>
   <p:notesSz cx="6858000" cy="9144000"/>
@@ -736,6 +737,72 @@
 </p:notes>
 </file>
 
+<file path=ppt/notesSlides/notesSlide6.xml><?xml version="1.0" encoding="utf-8"?>
+<p:notes xmlns:p="http://schemas.openxmlformats.org/presentationml/2006/main">
+  <p:cSld>
+    <p:spTree>
+      <p:nvGrpSpPr>
+        <p:cNvPr id="1" name=""/>
+        <p:cNvGrpSpPr/>
+        <p:nvPr/>
+      </p:nvGrpSpPr>
+      <p:grpSpPr>
+        <a:xfrm xmlns:a="http://schemas.openxmlformats.org/drawingml/2006/main"/>
+      </p:grpSpPr>
+      <p:sp>
+        <p:nvSpPr>
+          <p:cNvPr id="2" name="Slide Image Placeholder 1"/>
+          <p:cNvSpPr>
+            <a:spLocks xmlns:a="http://schemas.openxmlformats.org/drawingml/2006/main" noGrp="1"/>
+          </p:cNvSpPr>
+          <p:nvPr>
+            <p:ph type="sldImg" idx="0"/>
+          </p:nvPr>
+        </p:nvSpPr>
+        <p:spPr/>
+      </p:sp>
+      <p:sp>
+        <p:nvSpPr>
+          <p:cNvPr id="3" name="Notes Placeholder 2"/>
+          <p:cNvSpPr>
+            <a:spLocks xmlns:a="http://schemas.openxmlformats.org/drawingml/2006/main" noGrp="1"/>
+          </p:cNvSpPr>
+          <p:nvPr>
+            <p:ph type="body" idx="1"/>
+          </p:nvPr>
+        </p:nvSpPr>
+        <p:spPr/>
+        <p:txBody>
+          <a:bodyPr xmlns:a="http://schemas.openxmlformats.org/drawingml/2006/main"/>
+          <a:lstStyle xmlns:a="http://schemas.openxmlformats.org/drawingml/2006/main"/>
+          <a:p xmlns:a="http://schemas.openxmlformats.org/drawingml/2006/main"/>
+        </p:txBody>
+      </p:sp>
+      <p:sp>
+        <p:nvSpPr>
+          <p:cNvPr id="4" name="Slide Number Placeholder 3"/>
+          <p:cNvSpPr>
+            <a:spLocks xmlns:a="http://schemas.openxmlformats.org/drawingml/2006/main" noGrp="1"/>
+          </p:cNvSpPr>
+          <p:nvPr>
+            <p:ph type="sldNum" idx="5"/>
+          </p:nvPr>
+        </p:nvSpPr>
+        <p:spPr/>
+        <p:txBody>
+          <a:bodyPr xmlns:a="http://schemas.openxmlformats.org/drawingml/2006/main"/>
+          <a:lstStyle xmlns:a="http://schemas.openxmlformats.org/drawingml/2006/main"/>
+          <a:p xmlns:a="http://schemas.openxmlformats.org/drawingml/2006/main"/>
+        </p:txBody>
+      </p:sp>
+    </p:spTree>
+  </p:cSld>
+  <p:clrMapOvr>
+    <a:masterClrMapping xmlns:a="http://schemas.openxmlformats.org/drawingml/2006/main"/>
+  </p:clrMapOvr>
+</p:notes>
+</file>
+
 <file path=ppt/slideLayouts/slideLayout1.xml><?xml version="1.0" encoding="utf-8"?>
 <p:sldLayout xmlns:p="http://schemas.openxmlformats.org/presentationml/2006/main" type="title">
   <p:cSld name="Title Slide">
@@ -753,7 +820,7 @@
           <p:cNvPr id="3" name="Title">
             <a:extLst xmlns:a="http://schemas.openxmlformats.org/drawingml/2006/main">
               <a:ext uri="{FF2B5EF4-FFF2-40B4-BE49-F238E27FC236}">
-                <a16:creationId xmlns:a16="http://schemas.microsoft.com/office/drawing/2014/main" id="{4F358BA1-A343-4A5B-9360-85746B5440D1}"/>
+                <a16:creationId xmlns:a16="http://schemas.microsoft.com/office/drawing/2014/main" id="{DC73EF2A-BF5D-4219-8864-D1D080C273B5}"/>
               </a:ext>
             </a:extLst>
           </p:cNvPr>
@@ -910,7 +977,7 @@
           <p:cNvPr id="2" name="Subtitle">
             <a:extLst xmlns:a="http://schemas.openxmlformats.org/drawingml/2006/main">
               <a:ext uri="{FF2B5EF4-FFF2-40B4-BE49-F238E27FC236}">
-                <a16:creationId xmlns:a16="http://schemas.microsoft.com/office/drawing/2014/main" id="{FC959105-5043-4387-AE77-ABC2B41C1A37}"/>
+                <a16:creationId xmlns:a16="http://schemas.microsoft.com/office/drawing/2014/main" id="{73CD65F1-5B68-4EDB-B396-2E6AB3A67240}"/>
               </a:ext>
             </a:extLst>
           </p:cNvPr>
@@ -1084,7 +1151,7 @@
           <p:cNvPr id="2" name="Section title">
             <a:extLst xmlns:a="http://schemas.openxmlformats.org/drawingml/2006/main">
               <a:ext uri="{FF2B5EF4-FFF2-40B4-BE49-F238E27FC236}">
-                <a16:creationId xmlns:a16="http://schemas.microsoft.com/office/drawing/2014/main" id="{E0FBAAB0-A72F-433D-8AAC-448BB8793B0C}"/>
+                <a16:creationId xmlns:a16="http://schemas.microsoft.com/office/drawing/2014/main" id="{C21F639D-FA39-4E00-B681-2E8C384F2FB1}"/>
               </a:ext>
             </a:extLst>
           </p:cNvPr>
@@ -1258,7 +1325,7 @@
           <p:cNvPr id="3" name="Title">
             <a:extLst xmlns:a="http://schemas.openxmlformats.org/drawingml/2006/main">
               <a:ext uri="{FF2B5EF4-FFF2-40B4-BE49-F238E27FC236}">
-                <a16:creationId xmlns:a16="http://schemas.microsoft.com/office/drawing/2014/main" id="{F855660D-F93B-4F06-8A7B-E6978DF78052}"/>
+                <a16:creationId xmlns:a16="http://schemas.microsoft.com/office/drawing/2014/main" id="{1CE60036-D32D-438A-BA49-52290A9DB07E}"/>
               </a:ext>
             </a:extLst>
           </p:cNvPr>
@@ -1415,7 +1482,7 @@
           <p:cNvPr id="2" name="Body">
             <a:extLst xmlns:a="http://schemas.openxmlformats.org/drawingml/2006/main">
               <a:ext uri="{FF2B5EF4-FFF2-40B4-BE49-F238E27FC236}">
-                <a16:creationId xmlns:a16="http://schemas.microsoft.com/office/drawing/2014/main" id="{B4CB8C53-AD56-4A90-A098-7C9F9D473BED}"/>
+                <a16:creationId xmlns:a16="http://schemas.microsoft.com/office/drawing/2014/main" id="{161A9262-8526-4FF7-86C1-F7004E14FBE6}"/>
               </a:ext>
             </a:extLst>
           </p:cNvPr>
@@ -1589,7 +1656,7 @@
           <p:cNvPr id="4" name="Title">
             <a:extLst xmlns:a="http://schemas.openxmlformats.org/drawingml/2006/main">
               <a:ext uri="{FF2B5EF4-FFF2-40B4-BE49-F238E27FC236}">
-                <a16:creationId xmlns:a16="http://schemas.microsoft.com/office/drawing/2014/main" id="{69134A9B-4E89-4418-9391-F4166AD82522}"/>
+                <a16:creationId xmlns:a16="http://schemas.microsoft.com/office/drawing/2014/main" id="{B5869DF7-6C5D-478C-88BA-17678DE82154}"/>
               </a:ext>
             </a:extLst>
           </p:cNvPr>
@@ -1746,7 +1813,7 @@
           <p:cNvPr id="2" name="Left column">
             <a:extLst xmlns:a="http://schemas.openxmlformats.org/drawingml/2006/main">
               <a:ext uri="{FF2B5EF4-FFF2-40B4-BE49-F238E27FC236}">
-                <a16:creationId xmlns:a16="http://schemas.microsoft.com/office/drawing/2014/main" id="{1E81CDD0-B196-4645-BC5F-774ED035F179}"/>
+                <a16:creationId xmlns:a16="http://schemas.microsoft.com/office/drawing/2014/main" id="{25CF1BC8-5AE5-4B18-89B5-E58495E53356}"/>
               </a:ext>
             </a:extLst>
           </p:cNvPr>
@@ -1903,7 +1970,7 @@
           <p:cNvPr id="3" name="Right column">
             <a:extLst xmlns:a="http://schemas.openxmlformats.org/drawingml/2006/main">
               <a:ext uri="{FF2B5EF4-FFF2-40B4-BE49-F238E27FC236}">
-                <a16:creationId xmlns:a16="http://schemas.microsoft.com/office/drawing/2014/main" id="{97F3855D-F428-46DA-A678-F506B3394E3B}"/>
+                <a16:creationId xmlns:a16="http://schemas.microsoft.com/office/drawing/2014/main" id="{31707477-3FD9-4028-9FD9-B9E71138EB90}"/>
               </a:ext>
             </a:extLst>
           </p:cNvPr>
@@ -2077,7 +2144,7 @@
           <p:cNvPr id="3" name="Title">
             <a:extLst xmlns:a="http://schemas.openxmlformats.org/drawingml/2006/main">
               <a:ext uri="{FF2B5EF4-FFF2-40B4-BE49-F238E27FC236}">
-                <a16:creationId xmlns:a16="http://schemas.microsoft.com/office/drawing/2014/main" id="{3B403DB3-069A-4FF0-832B-F4D8FB8DD51F}"/>
+                <a16:creationId xmlns:a16="http://schemas.microsoft.com/office/drawing/2014/main" id="{9F2DA487-DDFB-44AB-A9D6-ED8F36DF6D5C}"/>
               </a:ext>
             </a:extLst>
           </p:cNvPr>
@@ -2234,7 +2301,7 @@
           <p:cNvPr id="2" name="Left column">
             <a:extLst xmlns:a="http://schemas.openxmlformats.org/drawingml/2006/main">
               <a:ext uri="{FF2B5EF4-FFF2-40B4-BE49-F238E27FC236}">
-                <a16:creationId xmlns:a16="http://schemas.microsoft.com/office/drawing/2014/main" id="{5BB1B912-A027-4E73-BC9A-F45E58A58D14}"/>
+                <a16:creationId xmlns:a16="http://schemas.microsoft.com/office/drawing/2014/main" id="{023FD54D-1D37-4496-9FBB-89B9AE9A4E25}"/>
               </a:ext>
             </a:extLst>
           </p:cNvPr>
@@ -2429,12 +2496,12 @@
   </p:cSld>
   <p:clrMap bg1="lt1" tx1="dk1" bg2="lt2" tx2="dk2" accent1="accent1" accent2="accent2" accent3="accent3" accent4="accent4" accent5="accent5" accent6="accent6" hlink="hlink" folHlink="folHlink"/>
   <p:sldLayoutIdLst>
-    <p:sldLayoutId xmlns:r="http://schemas.openxmlformats.org/officeDocument/2006/relationships" id="2147483649" r:id="R7d49f9868c5b473c"/>
-    <p:sldLayoutId xmlns:r="http://schemas.openxmlformats.org/officeDocument/2006/relationships" id="2147483650" r:id="Re5fb1e006ec6475e"/>
-    <p:sldLayoutId xmlns:r="http://schemas.openxmlformats.org/officeDocument/2006/relationships" id="2147483651" r:id="R9aac8bb467104eb3"/>
-    <p:sldLayoutId xmlns:r="http://schemas.openxmlformats.org/officeDocument/2006/relationships" id="2147483652" r:id="R9f4ea18bc4794d05"/>
-    <p:sldLayoutId xmlns:r="http://schemas.openxmlformats.org/officeDocument/2006/relationships" id="2147483653" r:id="R4ae3f59a0e824125"/>
-    <p:sldLayoutId xmlns:r="http://schemas.openxmlformats.org/officeDocument/2006/relationships" id="2147483654" r:id="Ra2dcb074f24d421d"/>
+    <p:sldLayoutId xmlns:r="http://schemas.openxmlformats.org/officeDocument/2006/relationships" id="2147483649" r:id="R0908eb9cfcc3479c"/>
+    <p:sldLayoutId xmlns:r="http://schemas.openxmlformats.org/officeDocument/2006/relationships" id="2147483650" r:id="R181e3c0a4bb449e0"/>
+    <p:sldLayoutId xmlns:r="http://schemas.openxmlformats.org/officeDocument/2006/relationships" id="2147483651" r:id="R3294f5edf771496c"/>
+    <p:sldLayoutId xmlns:r="http://schemas.openxmlformats.org/officeDocument/2006/relationships" id="2147483652" r:id="R7169a206560b4f8f"/>
+    <p:sldLayoutId xmlns:r="http://schemas.openxmlformats.org/officeDocument/2006/relationships" id="2147483653" r:id="Rd27e27cd1e694d6f"/>
+    <p:sldLayoutId xmlns:r="http://schemas.openxmlformats.org/officeDocument/2006/relationships" id="2147483654" r:id="R82bd6de837d142fa"/>
   </p:sldLayoutIdLst>
   <p:txStyles>
     <p:titleStyle>
@@ -2985,7 +3052,7 @@
           <p:cNvPr id="5" name="">
             <a:extLst xmlns:a="http://schemas.openxmlformats.org/drawingml/2006/main">
               <a:ext uri="{FF2B5EF4-FFF2-40B4-BE49-F238E27FC236}">
-                <a16:creationId xmlns:a16="http://schemas.microsoft.com/office/drawing/2014/main" id="{8BFA4359-A476-4B61-9AD3-7EEAF2991A3F}"/>
+                <a16:creationId xmlns:a16="http://schemas.microsoft.com/office/drawing/2014/main" id="{6FDD60DA-19BA-4425-BD03-3C7223D8FEA1}"/>
               </a:ext>
             </a:extLst>
           </p:cNvPr>
@@ -3043,7 +3110,7 @@
           <p:cNvPr id="2" name="">
             <a:extLst xmlns:a="http://schemas.openxmlformats.org/drawingml/2006/main">
               <a:ext uri="{FF2B5EF4-FFF2-40B4-BE49-F238E27FC236}">
-                <a16:creationId xmlns:a16="http://schemas.microsoft.com/office/drawing/2014/main" id="{48AF02A3-FB02-4A6C-9EBC-50511B103538}"/>
+                <a16:creationId xmlns:a16="http://schemas.microsoft.com/office/drawing/2014/main" id="{EE50CB28-07F7-49DE-BB3E-3254F0AE25A3}"/>
               </a:ext>
             </a:extLst>
           </p:cNvPr>
@@ -3101,7 +3168,7 @@
           <p:cNvPr id="3" name="">
             <a:extLst xmlns:a="http://schemas.openxmlformats.org/drawingml/2006/main">
               <a:ext uri="{FF2B5EF4-FFF2-40B4-BE49-F238E27FC236}">
-                <a16:creationId xmlns:a16="http://schemas.microsoft.com/office/drawing/2014/main" id="{5953BD6A-B026-456F-8654-F5677D896210}"/>
+                <a16:creationId xmlns:a16="http://schemas.microsoft.com/office/drawing/2014/main" id="{A7DE4762-82E7-4C91-833C-35E51FE32F13}"/>
               </a:ext>
             </a:extLst>
           </p:cNvPr>
@@ -3159,7 +3226,7 @@
           <p:cNvPr id="4" name="">
             <a:extLst xmlns:a="http://schemas.openxmlformats.org/drawingml/2006/main">
               <a:ext uri="{FF2B5EF4-FFF2-40B4-BE49-F238E27FC236}">
-                <a16:creationId xmlns:a16="http://schemas.microsoft.com/office/drawing/2014/main" id="{9BD6E76C-7B50-464C-8578-854A9FBBB7F9}"/>
+                <a16:creationId xmlns:a16="http://schemas.microsoft.com/office/drawing/2014/main" id="{0CF1D785-36AB-484B-9078-3123FABA707C}"/>
               </a:ext>
             </a:extLst>
           </p:cNvPr>
@@ -3215,7 +3282,7 @@
     </p:spTree>
     <p:extLst>
       <p:ext uri="{BB962C8B-B14F-4D97-AF65-F5344CB8AC3E}">
-        <p14:creationId xmlns:p14="http://schemas.microsoft.com/office/powerpoint/2010/main" val="13883563"/>
+        <p14:creationId xmlns:p14="http://schemas.microsoft.com/office/powerpoint/2010/main" val="1164470432"/>
       </p:ext>
     </p:extLst>
   </p:cSld>
@@ -3246,7 +3313,7 @@
           <p:cNvPr id="12" name="">
             <a:extLst xmlns:a="http://schemas.openxmlformats.org/drawingml/2006/main">
               <a:ext uri="{FF2B5EF4-FFF2-40B4-BE49-F238E27FC236}">
-                <a16:creationId xmlns:a16="http://schemas.microsoft.com/office/drawing/2014/main" id="{ABA3EED5-3D41-44CD-BD0E-114BA67BBD25}"/>
+                <a16:creationId xmlns:a16="http://schemas.microsoft.com/office/drawing/2014/main" id="{607EA4C8-2A7A-4B05-9A52-4F822E1E29D2}"/>
               </a:ext>
             </a:extLst>
           </p:cNvPr>
@@ -3304,7 +3371,7 @@
           <p:cNvPr id="2" name="">
             <a:extLst xmlns:a="http://schemas.openxmlformats.org/drawingml/2006/main">
               <a:ext uri="{FF2B5EF4-FFF2-40B4-BE49-F238E27FC236}">
-                <a16:creationId xmlns:a16="http://schemas.microsoft.com/office/drawing/2014/main" id="{7DE39F08-196E-4D0E-A42D-78D7CF894B7F}"/>
+                <a16:creationId xmlns:a16="http://schemas.microsoft.com/office/drawing/2014/main" id="{B0DE7887-AB17-4BF9-9082-A1BB3A6F6253}"/>
               </a:ext>
             </a:extLst>
           </p:cNvPr>
@@ -3362,7 +3429,7 @@
           <p:cNvPr id="3" name="">
             <a:extLst xmlns:a="http://schemas.openxmlformats.org/drawingml/2006/main">
               <a:ext uri="{FF2B5EF4-FFF2-40B4-BE49-F238E27FC236}">
-                <a16:creationId xmlns:a16="http://schemas.microsoft.com/office/drawing/2014/main" id="{92960CD9-E14B-4C44-8069-2EC47ACAFA56}"/>
+                <a16:creationId xmlns:a16="http://schemas.microsoft.com/office/drawing/2014/main" id="{E2B0DE2B-6997-49BB-8982-70E03C954E72}"/>
               </a:ext>
             </a:extLst>
           </p:cNvPr>
@@ -3395,7 +3462,7 @@
           <p:cNvPr id="4" name="">
             <a:extLst xmlns:a="http://schemas.openxmlformats.org/drawingml/2006/main">
               <a:ext uri="{FF2B5EF4-FFF2-40B4-BE49-F238E27FC236}">
-                <a16:creationId xmlns:a16="http://schemas.microsoft.com/office/drawing/2014/main" id="{C29BD77F-E85A-4D14-91E3-582AF67451B2}"/>
+                <a16:creationId xmlns:a16="http://schemas.microsoft.com/office/drawing/2014/main" id="{06F4DC74-329C-45A5-8C03-767BE29AD395}"/>
               </a:ext>
             </a:extLst>
           </p:cNvPr>
@@ -3453,7 +3520,7 @@
           <p:cNvPr id="5" name="">
             <a:extLst xmlns:a="http://schemas.openxmlformats.org/drawingml/2006/main">
               <a:ext uri="{FF2B5EF4-FFF2-40B4-BE49-F238E27FC236}">
-                <a16:creationId xmlns:a16="http://schemas.microsoft.com/office/drawing/2014/main" id="{24976182-25A4-4744-A67C-364559E2A84C}"/>
+                <a16:creationId xmlns:a16="http://schemas.microsoft.com/office/drawing/2014/main" id="{7D54D5B6-B9D1-495E-82D9-74753F56E0C6}"/>
               </a:ext>
             </a:extLst>
           </p:cNvPr>
@@ -3511,7 +3578,7 @@
           <p:cNvPr id="6" name="">
             <a:extLst xmlns:a="http://schemas.openxmlformats.org/drawingml/2006/main">
               <a:ext uri="{FF2B5EF4-FFF2-40B4-BE49-F238E27FC236}">
-                <a16:creationId xmlns:a16="http://schemas.microsoft.com/office/drawing/2014/main" id="{205A93EA-39B4-44C6-8B24-F0C5E309BD9E}"/>
+                <a16:creationId xmlns:a16="http://schemas.microsoft.com/office/drawing/2014/main" id="{C9AE291F-9BC0-4348-84A9-28DE672EC375}"/>
               </a:ext>
             </a:extLst>
           </p:cNvPr>
@@ -3569,7 +3636,7 @@
           <p:cNvPr id="7" name="">
             <a:extLst xmlns:a="http://schemas.openxmlformats.org/drawingml/2006/main">
               <a:ext uri="{FF2B5EF4-FFF2-40B4-BE49-F238E27FC236}">
-                <a16:creationId xmlns:a16="http://schemas.microsoft.com/office/drawing/2014/main" id="{10DB9ADA-05F3-4937-A8B9-D857A5447161}"/>
+                <a16:creationId xmlns:a16="http://schemas.microsoft.com/office/drawing/2014/main" id="{20C60461-EBF1-4C79-A4AF-415BFF971489}"/>
               </a:ext>
             </a:extLst>
           </p:cNvPr>
@@ -3627,7 +3694,7 @@
           <p:cNvPr id="8" name="">
             <a:extLst xmlns:a="http://schemas.openxmlformats.org/drawingml/2006/main">
               <a:ext uri="{FF2B5EF4-FFF2-40B4-BE49-F238E27FC236}">
-                <a16:creationId xmlns:a16="http://schemas.microsoft.com/office/drawing/2014/main" id="{27244191-F64D-48A3-B813-12A23B88431E}"/>
+                <a16:creationId xmlns:a16="http://schemas.microsoft.com/office/drawing/2014/main" id="{303BA92A-06E2-4E43-BE2A-939EF9F37876}"/>
               </a:ext>
             </a:extLst>
           </p:cNvPr>
@@ -3685,7 +3752,7 @@
           <p:cNvPr id="9" name="">
             <a:extLst xmlns:a="http://schemas.openxmlformats.org/drawingml/2006/main">
               <a:ext uri="{FF2B5EF4-FFF2-40B4-BE49-F238E27FC236}">
-                <a16:creationId xmlns:a16="http://schemas.microsoft.com/office/drawing/2014/main" id="{78F328E0-B509-423F-AB1A-DCBD0FAB9500}"/>
+                <a16:creationId xmlns:a16="http://schemas.microsoft.com/office/drawing/2014/main" id="{706EC18E-7939-4B8E-9D5C-BEF8C5CC1687}"/>
               </a:ext>
             </a:extLst>
           </p:cNvPr>
@@ -3743,7 +3810,7 @@
           <p:cNvPr id="10" name="">
             <a:extLst xmlns:a="http://schemas.openxmlformats.org/drawingml/2006/main">
               <a:ext uri="{FF2B5EF4-FFF2-40B4-BE49-F238E27FC236}">
-                <a16:creationId xmlns:a16="http://schemas.microsoft.com/office/drawing/2014/main" id="{DC4791B5-9711-419B-BC0B-FC69F50E9671}"/>
+                <a16:creationId xmlns:a16="http://schemas.microsoft.com/office/drawing/2014/main" id="{85D1323E-0DC5-4742-B0F0-71F6ACF8DF95}"/>
               </a:ext>
             </a:extLst>
           </p:cNvPr>
@@ -3801,7 +3868,7 @@
           <p:cNvPr id="11" name="">
             <a:extLst xmlns:a="http://schemas.openxmlformats.org/drawingml/2006/main">
               <a:ext uri="{FF2B5EF4-FFF2-40B4-BE49-F238E27FC236}">
-                <a16:creationId xmlns:a16="http://schemas.microsoft.com/office/drawing/2014/main" id="{99976109-0FCB-4B74-94AA-F4E88DA958BB}"/>
+                <a16:creationId xmlns:a16="http://schemas.microsoft.com/office/drawing/2014/main" id="{06FF9775-3993-4338-AC90-4FEBD84603B2}"/>
               </a:ext>
             </a:extLst>
           </p:cNvPr>
@@ -3857,7 +3924,7 @@
     </p:spTree>
     <p:extLst>
       <p:ext uri="{BB962C8B-B14F-4D97-AF65-F5344CB8AC3E}">
-        <p14:creationId xmlns:p14="http://schemas.microsoft.com/office/powerpoint/2010/main" val="1109364961"/>
+        <p14:creationId xmlns:p14="http://schemas.microsoft.com/office/powerpoint/2010/main" val="885624355"/>
       </p:ext>
     </p:extLst>
   </p:cSld>
@@ -3888,7 +3955,7 @@
           <p:cNvPr id="14" name="">
             <a:extLst xmlns:a="http://schemas.openxmlformats.org/drawingml/2006/main">
               <a:ext uri="{FF2B5EF4-FFF2-40B4-BE49-F238E27FC236}">
-                <a16:creationId xmlns:a16="http://schemas.microsoft.com/office/drawing/2014/main" id="{802D10C9-6CE4-4246-A9B2-C85E980DF4AE}"/>
+                <a16:creationId xmlns:a16="http://schemas.microsoft.com/office/drawing/2014/main" id="{7B526AF9-5EAC-4928-B866-68F7EB1F5BE5}"/>
               </a:ext>
             </a:extLst>
           </p:cNvPr>
@@ -3946,7 +4013,7 @@
           <p:cNvPr id="2" name="">
             <a:extLst xmlns:a="http://schemas.openxmlformats.org/drawingml/2006/main">
               <a:ext uri="{FF2B5EF4-FFF2-40B4-BE49-F238E27FC236}">
-                <a16:creationId xmlns:a16="http://schemas.microsoft.com/office/drawing/2014/main" id="{A1D63EBC-C36C-4F7B-B341-FFF8BF5880CF}"/>
+                <a16:creationId xmlns:a16="http://schemas.microsoft.com/office/drawing/2014/main" id="{39996A9D-5345-4662-A6D1-6679701DB24A}"/>
               </a:ext>
             </a:extLst>
           </p:cNvPr>
@@ -4004,7 +4071,7 @@
           <p:cNvPr id="3" name="">
             <a:extLst xmlns:a="http://schemas.openxmlformats.org/drawingml/2006/main">
               <a:ext uri="{FF2B5EF4-FFF2-40B4-BE49-F238E27FC236}">
-                <a16:creationId xmlns:a16="http://schemas.microsoft.com/office/drawing/2014/main" id="{622D0912-B42B-444D-BAF6-5E8C0D80D667}"/>
+                <a16:creationId xmlns:a16="http://schemas.microsoft.com/office/drawing/2014/main" id="{2BC3B279-0353-430E-B8D7-FFEA563DDE3B}"/>
               </a:ext>
             </a:extLst>
           </p:cNvPr>
@@ -4037,7 +4104,7 @@
           <p:cNvPr id="4" name="">
             <a:extLst xmlns:a="http://schemas.openxmlformats.org/drawingml/2006/main">
               <a:ext uri="{FF2B5EF4-FFF2-40B4-BE49-F238E27FC236}">
-                <a16:creationId xmlns:a16="http://schemas.microsoft.com/office/drawing/2014/main" id="{13D8BC1C-33CC-43A4-AD96-92FBCB0167E6}"/>
+                <a16:creationId xmlns:a16="http://schemas.microsoft.com/office/drawing/2014/main" id="{4E98A91A-44EF-4DC5-9603-4CA0706CF491}"/>
               </a:ext>
             </a:extLst>
           </p:cNvPr>
@@ -4070,7 +4137,7 @@
           <p:cNvPr id="5" name="">
             <a:extLst xmlns:a="http://schemas.openxmlformats.org/drawingml/2006/main">
               <a:ext uri="{FF2B5EF4-FFF2-40B4-BE49-F238E27FC236}">
-                <a16:creationId xmlns:a16="http://schemas.microsoft.com/office/drawing/2014/main" id="{A7AEDB2A-B792-4F1C-B074-BE360AB960AB}"/>
+                <a16:creationId xmlns:a16="http://schemas.microsoft.com/office/drawing/2014/main" id="{D46F4D87-4B31-484F-8169-55C6C79AF9BD}"/>
               </a:ext>
             </a:extLst>
           </p:cNvPr>
@@ -4128,7 +4195,7 @@
           <p:cNvPr id="6" name="">
             <a:extLst xmlns:a="http://schemas.openxmlformats.org/drawingml/2006/main">
               <a:ext uri="{FF2B5EF4-FFF2-40B4-BE49-F238E27FC236}">
-                <a16:creationId xmlns:a16="http://schemas.microsoft.com/office/drawing/2014/main" id="{5A463D11-7890-44F6-BB32-0DDF13A584EF}"/>
+                <a16:creationId xmlns:a16="http://schemas.microsoft.com/office/drawing/2014/main" id="{48E1DB54-227D-43E0-AF2E-B40784DD6C53}"/>
               </a:ext>
             </a:extLst>
           </p:cNvPr>
@@ -4186,7 +4253,7 @@
           <p:cNvPr id="7" name="">
             <a:extLst xmlns:a="http://schemas.openxmlformats.org/drawingml/2006/main">
               <a:ext uri="{FF2B5EF4-FFF2-40B4-BE49-F238E27FC236}">
-                <a16:creationId xmlns:a16="http://schemas.microsoft.com/office/drawing/2014/main" id="{D0ECA373-4E24-4595-B550-7EEA3529F940}"/>
+                <a16:creationId xmlns:a16="http://schemas.microsoft.com/office/drawing/2014/main" id="{12B8A76F-647F-499E-836F-E8FA2781DCD6}"/>
               </a:ext>
             </a:extLst>
           </p:cNvPr>
@@ -4219,7 +4286,7 @@
           <p:cNvPr id="8" name="">
             <a:extLst xmlns:a="http://schemas.openxmlformats.org/drawingml/2006/main">
               <a:ext uri="{FF2B5EF4-FFF2-40B4-BE49-F238E27FC236}">
-                <a16:creationId xmlns:a16="http://schemas.microsoft.com/office/drawing/2014/main" id="{1B8698F2-509A-4E77-B0D8-BDF603F58C98}"/>
+                <a16:creationId xmlns:a16="http://schemas.microsoft.com/office/drawing/2014/main" id="{4D9C1D6C-7169-41E4-9B80-386A00F88ACD}"/>
               </a:ext>
             </a:extLst>
           </p:cNvPr>
@@ -4277,7 +4344,7 @@
           <p:cNvPr id="9" name="">
             <a:extLst xmlns:a="http://schemas.openxmlformats.org/drawingml/2006/main">
               <a:ext uri="{FF2B5EF4-FFF2-40B4-BE49-F238E27FC236}">
-                <a16:creationId xmlns:a16="http://schemas.microsoft.com/office/drawing/2014/main" id="{148687C6-8622-4155-83B4-9A676B8FF65E}"/>
+                <a16:creationId xmlns:a16="http://schemas.microsoft.com/office/drawing/2014/main" id="{F4A7B2D2-5BD3-4672-B40C-71EF228476F6}"/>
               </a:ext>
             </a:extLst>
           </p:cNvPr>
@@ -4335,7 +4402,7 @@
           <p:cNvPr id="10" name="">
             <a:extLst xmlns:a="http://schemas.openxmlformats.org/drawingml/2006/main">
               <a:ext uri="{FF2B5EF4-FFF2-40B4-BE49-F238E27FC236}">
-                <a16:creationId xmlns:a16="http://schemas.microsoft.com/office/drawing/2014/main" id="{28326744-0610-484C-9383-9766F681647A}"/>
+                <a16:creationId xmlns:a16="http://schemas.microsoft.com/office/drawing/2014/main" id="{29EF5ED4-A989-43A5-9461-8C7B5BF6CC43}"/>
               </a:ext>
             </a:extLst>
           </p:cNvPr>
@@ -4368,7 +4435,7 @@
           <p:cNvPr id="11" name="">
             <a:extLst xmlns:a="http://schemas.openxmlformats.org/drawingml/2006/main">
               <a:ext uri="{FF2B5EF4-FFF2-40B4-BE49-F238E27FC236}">
-                <a16:creationId xmlns:a16="http://schemas.microsoft.com/office/drawing/2014/main" id="{C662A580-0F5D-4FB7-9E58-389BEA51DD9D}"/>
+                <a16:creationId xmlns:a16="http://schemas.microsoft.com/office/drawing/2014/main" id="{56601304-0E36-4F92-AFF3-27AD4306534A}"/>
               </a:ext>
             </a:extLst>
           </p:cNvPr>
@@ -4426,7 +4493,7 @@
           <p:cNvPr id="12" name="">
             <a:extLst xmlns:a="http://schemas.openxmlformats.org/drawingml/2006/main">
               <a:ext uri="{FF2B5EF4-FFF2-40B4-BE49-F238E27FC236}">
-                <a16:creationId xmlns:a16="http://schemas.microsoft.com/office/drawing/2014/main" id="{07ABD160-1EBE-461D-9964-CC61A6B06E32}"/>
+                <a16:creationId xmlns:a16="http://schemas.microsoft.com/office/drawing/2014/main" id="{8A8FAD89-B37B-4EC6-9174-79215501333F}"/>
               </a:ext>
             </a:extLst>
           </p:cNvPr>
@@ -4484,7 +4551,7 @@
           <p:cNvPr id="13" name="">
             <a:extLst xmlns:a="http://schemas.openxmlformats.org/drawingml/2006/main">
               <a:ext uri="{FF2B5EF4-FFF2-40B4-BE49-F238E27FC236}">
-                <a16:creationId xmlns:a16="http://schemas.microsoft.com/office/drawing/2014/main" id="{8A75D458-9833-4EEA-90CC-AF1781501FE4}"/>
+                <a16:creationId xmlns:a16="http://schemas.microsoft.com/office/drawing/2014/main" id="{0F3D145D-D446-4C95-B74E-C705383B9D3B}"/>
               </a:ext>
             </a:extLst>
           </p:cNvPr>
@@ -4540,7 +4607,7 @@
     </p:spTree>
     <p:extLst>
       <p:ext uri="{BB962C8B-B14F-4D97-AF65-F5344CB8AC3E}">
-        <p14:creationId xmlns:p14="http://schemas.microsoft.com/office/powerpoint/2010/main" val="496430782"/>
+        <p14:creationId xmlns:p14="http://schemas.microsoft.com/office/powerpoint/2010/main" val="833737599"/>
       </p:ext>
     </p:extLst>
   </p:cSld>
@@ -4568,10 +4635,10 @@
       </p:grpSpPr>
       <p:sp>
         <p:nvSpPr>
-          <p:cNvPr id="12" name="">
-            <a:extLst xmlns:a="http://schemas.openxmlformats.org/drawingml/2006/main">
-              <a:ext uri="{FF2B5EF4-FFF2-40B4-BE49-F238E27FC236}">
-                <a16:creationId xmlns:a16="http://schemas.microsoft.com/office/drawing/2014/main" id="{C7EC2CFB-11A1-4663-9EAC-56A46CA8C5CC}"/>
+          <p:cNvPr id="14" name="">
+            <a:extLst xmlns:a="http://schemas.openxmlformats.org/drawingml/2006/main">
+              <a:ext uri="{FF2B5EF4-FFF2-40B4-BE49-F238E27FC236}">
+                <a16:creationId xmlns:a16="http://schemas.microsoft.com/office/drawing/2014/main" id="{58296CF2-54C8-4C7A-8A3C-8BB6440FF102}"/>
               </a:ext>
             </a:extLst>
           </p:cNvPr>
@@ -4629,7 +4696,7 @@
           <p:cNvPr id="2" name="">
             <a:extLst xmlns:a="http://schemas.openxmlformats.org/drawingml/2006/main">
               <a:ext uri="{FF2B5EF4-FFF2-40B4-BE49-F238E27FC236}">
-                <a16:creationId xmlns:a16="http://schemas.microsoft.com/office/drawing/2014/main" id="{987DAECC-0666-4F70-939F-12B29353EAB3}"/>
+                <a16:creationId xmlns:a16="http://schemas.microsoft.com/office/drawing/2014/main" id="{CC0C7157-D6B7-4FEF-816C-FB1B06F8AEE0}"/>
               </a:ext>
             </a:extLst>
           </p:cNvPr>
@@ -4677,7 +4744,7 @@
                   <a:srgbClr val="153F35"/>
                 </a:solidFill>
               </a:rPr>
-              <a:t>Ratings Room operating system</a:t>
+              <a:t>A script now runs the weekly pulse</a:t>
             </a:r>
           </a:p>
         </p:txBody>
@@ -4687,7 +4754,7 @@
           <p:cNvPr id="3" name="">
             <a:extLst xmlns:a="http://schemas.openxmlformats.org/drawingml/2006/main">
               <a:ext uri="{FF2B5EF4-FFF2-40B4-BE49-F238E27FC236}">
-                <a16:creationId xmlns:a16="http://schemas.microsoft.com/office/drawing/2014/main" id="{509002CC-1488-4FFB-8899-4E1BB830BC1E}"/>
+                <a16:creationId xmlns:a16="http://schemas.microsoft.com/office/drawing/2014/main" id="{5AD112C2-812D-459B-8A80-7ADB43FDD9C3}"/>
               </a:ext>
             </a:extLst>
           </p:cNvPr>
@@ -4720,7 +4787,7 @@
           <p:cNvPr id="4" name="">
             <a:extLst xmlns:a="http://schemas.openxmlformats.org/drawingml/2006/main">
               <a:ext uri="{FF2B5EF4-FFF2-40B4-BE49-F238E27FC236}">
-                <a16:creationId xmlns:a16="http://schemas.microsoft.com/office/drawing/2014/main" id="{025D97FB-5049-4D96-914D-5522F75E0FD0}"/>
+                <a16:creationId xmlns:a16="http://schemas.microsoft.com/office/drawing/2014/main" id="{30D5253D-92DE-4E42-B479-CC999B05FA5D}"/>
               </a:ext>
             </a:extLst>
           </p:cNvPr>
@@ -4731,8 +4798,41 @@
         </p:nvSpPr>
         <p:spPr>
           <a:xfrm xmlns:a="http://schemas.openxmlformats.org/drawingml/2006/main">
-            <a:off x="857250" y="2000250"/>
-            <a:ext cx="228600" cy="266700"/>
+            <a:off x="762000" y="2000250"/>
+            <a:ext cx="3238500" cy="2190750"/>
+          </a:xfrm>
+          <a:prstGeom xmlns:a="http://schemas.openxmlformats.org/drawingml/2006/main" prst="rect">
+            <a:avLst/>
+          </a:prstGeom>
+          <a:solidFill xmlns:a="http://schemas.openxmlformats.org/drawingml/2006/main">
+            <a:srgbClr val="FFFFFF"/>
+          </a:solidFill>
+          <a:ln xmlns:a="http://schemas.openxmlformats.org/drawingml/2006/main" w="9525">
+            <a:solidFill>
+              <a:srgbClr val="C7DED5"/>
+            </a:solidFill>
+            <a:prstDash val="solid"/>
+          </a:ln>
+        </p:spPr>
+      </p:sp>
+      <p:sp>
+        <p:nvSpPr>
+          <p:cNvPr id="5" name="">
+            <a:extLst xmlns:a="http://schemas.openxmlformats.org/drawingml/2006/main">
+              <a:ext uri="{FF2B5EF4-FFF2-40B4-BE49-F238E27FC236}">
+                <a16:creationId xmlns:a16="http://schemas.microsoft.com/office/drawing/2014/main" id="{D578BB2B-408C-42B6-9C93-8EBE610204D6}"/>
+              </a:ext>
+            </a:extLst>
+          </p:cNvPr>
+          <p:cNvSpPr>
+            <a:spLocks xmlns:a="http://schemas.openxmlformats.org/drawingml/2006/main" noGrp="1"/>
+          </p:cNvSpPr>
+          <p:nvPr/>
+        </p:nvSpPr>
+        <p:spPr>
+          <a:xfrm xmlns:a="http://schemas.openxmlformats.org/drawingml/2006/main">
+            <a:off x="971550" y="2190750"/>
+            <a:ext cx="2819400" cy="285750"/>
           </a:xfrm>
           <a:prstGeom xmlns:a="http://schemas.openxmlformats.org/drawingml/2006/main" prst="rect">
             <a:avLst/>
@@ -4747,38 +4847,38 @@
           <a:bodyPr xmlns:a="http://schemas.openxmlformats.org/drawingml/2006/main"/>
           <a:lstStyle xmlns:a="http://schemas.openxmlformats.org/drawingml/2006/main">
             <a:defPPr>
-              <a:defRPr sz="1650" b="1">
-                <a:solidFill>
-                  <a:srgbClr val="245345"/>
+              <a:defRPr sz="1575" b="1">
+                <a:solidFill>
+                  <a:srgbClr val="153F35"/>
                 </a:solidFill>
               </a:defRPr>
             </a:defPPr>
           </a:lstStyle>
           <a:p xmlns:a="http://schemas.openxmlformats.org/drawingml/2006/main">
             <a:pPr>
-              <a:defRPr sz="1650" b="1">
-                <a:solidFill>
-                  <a:srgbClr val="245345"/>
+              <a:defRPr sz="1575" b="1">
+                <a:solidFill>
+                  <a:srgbClr val="153F35"/>
                 </a:solidFill>
               </a:defRPr>
             </a:pPr>
             <a:r>
-              <a:rPr sz="1650" b="1">
-                <a:solidFill>
-                  <a:srgbClr val="245345"/>
+              <a:rPr sz="1575" b="1">
+                <a:solidFill>
+                  <a:srgbClr val="153F35"/>
                 </a:solidFill>
               </a:rPr>
-              <a:t>•</a:t>
+              <a:t>Public review pull</a:t>
             </a:r>
           </a:p>
         </p:txBody>
       </p:sp>
       <p:sp>
         <p:nvSpPr>
-          <p:cNvPr id="5" name="">
-            <a:extLst xmlns:a="http://schemas.openxmlformats.org/drawingml/2006/main">
-              <a:ext uri="{FF2B5EF4-FFF2-40B4-BE49-F238E27FC236}">
-                <a16:creationId xmlns:a16="http://schemas.microsoft.com/office/drawing/2014/main" id="{F14D8D17-1102-4767-A047-2A89FF6AE0CA}"/>
+          <p:cNvPr id="6" name="">
+            <a:extLst xmlns:a="http://schemas.openxmlformats.org/drawingml/2006/main">
+              <a:ext uri="{FF2B5EF4-FFF2-40B4-BE49-F238E27FC236}">
+                <a16:creationId xmlns:a16="http://schemas.microsoft.com/office/drawing/2014/main" id="{014B0142-5910-496B-A953-7790A22D1FA5}"/>
               </a:ext>
             </a:extLst>
           </p:cNvPr>
@@ -4789,8 +4889,8 @@
         </p:nvSpPr>
         <p:spPr>
           <a:xfrm xmlns:a="http://schemas.openxmlformats.org/drawingml/2006/main">
-            <a:off x="1181100" y="2000250"/>
-            <a:ext cx="9486900" cy="361950"/>
+            <a:off x="971550" y="2590800"/>
+            <a:ext cx="2819400" cy="1428750"/>
           </a:xfrm>
           <a:prstGeom xmlns:a="http://schemas.openxmlformats.org/drawingml/2006/main" prst="rect">
             <a:avLst/>
@@ -4805,7 +4905,7 @@
           <a:bodyPr xmlns:a="http://schemas.openxmlformats.org/drawingml/2006/main"/>
           <a:lstStyle xmlns:a="http://schemas.openxmlformats.org/drawingml/2006/main">
             <a:defPPr>
-              <a:defRPr sz="1650" b="0">
+              <a:defRPr sz="1275" b="0">
                 <a:solidFill>
                   <a:srgbClr val="202624"/>
                 </a:solidFill>
@@ -4814,29 +4914,29 @@
           </a:lstStyle>
           <a:p xmlns:a="http://schemas.openxmlformats.org/drawingml/2006/main">
             <a:pPr>
-              <a:defRPr sz="1650" b="0">
+              <a:defRPr sz="1275" b="0">
                 <a:solidFill>
                   <a:srgbClr val="202624"/>
                 </a:solidFill>
               </a:defRPr>
             </a:pPr>
             <a:r>
-              <a:rPr sz="1650" b="0">
+              <a:rPr sz="1275" b="0">
                 <a:solidFill>
                   <a:srgbClr val="202624"/>
                 </a:solidFill>
               </a:rPr>
-              <a:t>Ingest Play reviews, ratings, app version, device data, developer replies, and internal trip telemetry.</a:t>
+              <a:t>play_pulse.py reads recent Play reviews, ratings, versions, replies, and review text themes.</a:t>
             </a:r>
           </a:p>
         </p:txBody>
       </p:sp>
       <p:sp>
         <p:nvSpPr>
-          <p:cNvPr id="6" name="">
-            <a:extLst xmlns:a="http://schemas.openxmlformats.org/drawingml/2006/main">
-              <a:ext uri="{FF2B5EF4-FFF2-40B4-BE49-F238E27FC236}">
-                <a16:creationId xmlns:a16="http://schemas.microsoft.com/office/drawing/2014/main" id="{EB1BE6FE-C2C4-4F15-BE79-04165476FCAB}"/>
+          <p:cNvPr id="7" name="">
+            <a:extLst xmlns:a="http://schemas.openxmlformats.org/drawingml/2006/main">
+              <a:ext uri="{FF2B5EF4-FFF2-40B4-BE49-F238E27FC236}">
+                <a16:creationId xmlns:a16="http://schemas.microsoft.com/office/drawing/2014/main" id="{6E93F54A-B7D8-4C64-9DCB-8CF1BB149962}"/>
               </a:ext>
             </a:extLst>
           </p:cNvPr>
@@ -4847,8 +4947,41 @@
         </p:nvSpPr>
         <p:spPr>
           <a:xfrm xmlns:a="http://schemas.openxmlformats.org/drawingml/2006/main">
-            <a:off x="857250" y="2686050"/>
-            <a:ext cx="228600" cy="266700"/>
+            <a:off x="4476750" y="2000250"/>
+            <a:ext cx="3238500" cy="2190750"/>
+          </a:xfrm>
+          <a:prstGeom xmlns:a="http://schemas.openxmlformats.org/drawingml/2006/main" prst="rect">
+            <a:avLst/>
+          </a:prstGeom>
+          <a:solidFill xmlns:a="http://schemas.openxmlformats.org/drawingml/2006/main">
+            <a:srgbClr val="FFFFFF"/>
+          </a:solidFill>
+          <a:ln xmlns:a="http://schemas.openxmlformats.org/drawingml/2006/main" w="9525">
+            <a:solidFill>
+              <a:srgbClr val="C7DED5"/>
+            </a:solidFill>
+            <a:prstDash val="solid"/>
+          </a:ln>
+        </p:spPr>
+      </p:sp>
+      <p:sp>
+        <p:nvSpPr>
+          <p:cNvPr id="8" name="">
+            <a:extLst xmlns:a="http://schemas.openxmlformats.org/drawingml/2006/main">
+              <a:ext uri="{FF2B5EF4-FFF2-40B4-BE49-F238E27FC236}">
+                <a16:creationId xmlns:a16="http://schemas.microsoft.com/office/drawing/2014/main" id="{44D61331-920E-40D6-A4A4-FF3C21A9B7E4}"/>
+              </a:ext>
+            </a:extLst>
+          </p:cNvPr>
+          <p:cNvSpPr>
+            <a:spLocks xmlns:a="http://schemas.openxmlformats.org/drawingml/2006/main" noGrp="1"/>
+          </p:cNvSpPr>
+          <p:nvPr/>
+        </p:nvSpPr>
+        <p:spPr>
+          <a:xfrm xmlns:a="http://schemas.openxmlformats.org/drawingml/2006/main">
+            <a:off x="4686300" y="2190750"/>
+            <a:ext cx="2819400" cy="285750"/>
           </a:xfrm>
           <a:prstGeom xmlns:a="http://schemas.openxmlformats.org/drawingml/2006/main" prst="rect">
             <a:avLst/>
@@ -4863,38 +4996,38 @@
           <a:bodyPr xmlns:a="http://schemas.openxmlformats.org/drawingml/2006/main"/>
           <a:lstStyle xmlns:a="http://schemas.openxmlformats.org/drawingml/2006/main">
             <a:defPPr>
-              <a:defRPr sz="1650" b="1">
-                <a:solidFill>
-                  <a:srgbClr val="245345"/>
+              <a:defRPr sz="1575" b="1">
+                <a:solidFill>
+                  <a:srgbClr val="153F35"/>
                 </a:solidFill>
               </a:defRPr>
             </a:defPPr>
           </a:lstStyle>
           <a:p xmlns:a="http://schemas.openxmlformats.org/drawingml/2006/main">
             <a:pPr>
-              <a:defRPr sz="1650" b="1">
-                <a:solidFill>
-                  <a:srgbClr val="245345"/>
+              <a:defRPr sz="1575" b="1">
+                <a:solidFill>
+                  <a:srgbClr val="153F35"/>
                 </a:solidFill>
               </a:defRPr>
             </a:pPr>
             <a:r>
-              <a:rPr sz="1650" b="1">
-                <a:solidFill>
-                  <a:srgbClr val="245345"/>
+              <a:rPr sz="1575" b="1">
+                <a:solidFill>
+                  <a:srgbClr val="153F35"/>
                 </a:solidFill>
               </a:rPr>
-              <a:t>•</a:t>
+              <a:t>Latest run</a:t>
             </a:r>
           </a:p>
         </p:txBody>
       </p:sp>
       <p:sp>
         <p:nvSpPr>
-          <p:cNvPr id="7" name="">
-            <a:extLst xmlns:a="http://schemas.openxmlformats.org/drawingml/2006/main">
-              <a:ext uri="{FF2B5EF4-FFF2-40B4-BE49-F238E27FC236}">
-                <a16:creationId xmlns:a16="http://schemas.microsoft.com/office/drawing/2014/main" id="{F03DDBFD-5EE9-4092-8BCD-7323FC9ECF91}"/>
+          <p:cNvPr id="9" name="">
+            <a:extLst xmlns:a="http://schemas.openxmlformats.org/drawingml/2006/main">
+              <a:ext uri="{FF2B5EF4-FFF2-40B4-BE49-F238E27FC236}">
+                <a16:creationId xmlns:a16="http://schemas.microsoft.com/office/drawing/2014/main" id="{974B367F-CEB3-4F09-B346-60D35302FF4C}"/>
               </a:ext>
             </a:extLst>
           </p:cNvPr>
@@ -4905,8 +5038,8 @@
         </p:nvSpPr>
         <p:spPr>
           <a:xfrm xmlns:a="http://schemas.openxmlformats.org/drawingml/2006/main">
-            <a:off x="1181100" y="2686050"/>
-            <a:ext cx="9486900" cy="361950"/>
+            <a:off x="4686300" y="2590800"/>
+            <a:ext cx="2819400" cy="1428750"/>
           </a:xfrm>
           <a:prstGeom xmlns:a="http://schemas.openxmlformats.org/drawingml/2006/main" prst="rect">
             <a:avLst/>
@@ -4921,7 +5054,7 @@
           <a:bodyPr xmlns:a="http://schemas.openxmlformats.org/drawingml/2006/main"/>
           <a:lstStyle xmlns:a="http://schemas.openxmlformats.org/drawingml/2006/main">
             <a:defPPr>
-              <a:defRPr sz="1650" b="0">
+              <a:defRPr sz="1275" b="0">
                 <a:solidFill>
                   <a:srgbClr val="202624"/>
                 </a:solidFill>
@@ -4930,29 +5063,29 @@
           </a:lstStyle>
           <a:p xmlns:a="http://schemas.openxmlformats.org/drawingml/2006/main">
             <a:pPr>
-              <a:defRPr sz="1650" b="0">
+              <a:defRPr sz="1275" b="0">
                 <a:solidFill>
                   <a:srgbClr val="202624"/>
                 </a:solidFill>
               </a:defRPr>
             </a:pPr>
             <a:r>
-              <a:rPr sz="1650" b="0">
+              <a:rPr sz="1275" b="0">
                 <a:solidFill>
                   <a:srgbClr val="202624"/>
                 </a:solidFill>
               </a:rPr>
-              <a:t>Tag every review by trip stage, product theme, severity, owner, and recovery status.</a:t>
+              <a:t>On 2026-10-13 it read 235 written reviews from the last 30 days and 223 from the prior 30 days.</a:t>
             </a:r>
           </a:p>
         </p:txBody>
       </p:sp>
       <p:sp>
         <p:nvSpPr>
-          <p:cNvPr id="8" name="">
-            <a:extLst xmlns:a="http://schemas.openxmlformats.org/drawingml/2006/main">
-              <a:ext uri="{FF2B5EF4-FFF2-40B4-BE49-F238E27FC236}">
-                <a16:creationId xmlns:a16="http://schemas.microsoft.com/office/drawing/2014/main" id="{A1E1902D-0722-4BBD-AE6A-DF5E84A53F88}"/>
+          <p:cNvPr id="10" name="">
+            <a:extLst xmlns:a="http://schemas.openxmlformats.org/drawingml/2006/main">
+              <a:ext uri="{FF2B5EF4-FFF2-40B4-BE49-F238E27FC236}">
+                <a16:creationId xmlns:a16="http://schemas.microsoft.com/office/drawing/2014/main" id="{30F45B02-7E6A-4A89-B170-517C2A0B025D}"/>
               </a:ext>
             </a:extLst>
           </p:cNvPr>
@@ -4963,8 +5096,41 @@
         </p:nvSpPr>
         <p:spPr>
           <a:xfrm xmlns:a="http://schemas.openxmlformats.org/drawingml/2006/main">
-            <a:off x="857250" y="3371850"/>
-            <a:ext cx="228600" cy="266700"/>
+            <a:off x="8191500" y="2000250"/>
+            <a:ext cx="3238500" cy="2190750"/>
+          </a:xfrm>
+          <a:prstGeom xmlns:a="http://schemas.openxmlformats.org/drawingml/2006/main" prst="rect">
+            <a:avLst/>
+          </a:prstGeom>
+          <a:solidFill xmlns:a="http://schemas.openxmlformats.org/drawingml/2006/main">
+            <a:srgbClr val="FFFFFF"/>
+          </a:solidFill>
+          <a:ln xmlns:a="http://schemas.openxmlformats.org/drawingml/2006/main" w="9525">
+            <a:solidFill>
+              <a:srgbClr val="C7DED5"/>
+            </a:solidFill>
+            <a:prstDash val="solid"/>
+          </a:ln>
+        </p:spPr>
+      </p:sp>
+      <p:sp>
+        <p:nvSpPr>
+          <p:cNvPr id="11" name="">
+            <a:extLst xmlns:a="http://schemas.openxmlformats.org/drawingml/2006/main">
+              <a:ext uri="{FF2B5EF4-FFF2-40B4-BE49-F238E27FC236}">
+                <a16:creationId xmlns:a16="http://schemas.microsoft.com/office/drawing/2014/main" id="{F1047DA4-3527-44FB-833B-DAA339421751}"/>
+              </a:ext>
+            </a:extLst>
+          </p:cNvPr>
+          <p:cNvSpPr>
+            <a:spLocks xmlns:a="http://schemas.openxmlformats.org/drawingml/2006/main" noGrp="1"/>
+          </p:cNvSpPr>
+          <p:nvPr/>
+        </p:nvSpPr>
+        <p:spPr>
+          <a:xfrm xmlns:a="http://schemas.openxmlformats.org/drawingml/2006/main">
+            <a:off x="8401050" y="2190750"/>
+            <a:ext cx="2819400" cy="285750"/>
           </a:xfrm>
           <a:prstGeom xmlns:a="http://schemas.openxmlformats.org/drawingml/2006/main" prst="rect">
             <a:avLst/>
@@ -4979,38 +5145,38 @@
           <a:bodyPr xmlns:a="http://schemas.openxmlformats.org/drawingml/2006/main"/>
           <a:lstStyle xmlns:a="http://schemas.openxmlformats.org/drawingml/2006/main">
             <a:defPPr>
-              <a:defRPr sz="1650" b="1">
-                <a:solidFill>
-                  <a:srgbClr val="245345"/>
+              <a:defRPr sz="1575" b="1">
+                <a:solidFill>
+                  <a:srgbClr val="153F35"/>
                 </a:solidFill>
               </a:defRPr>
             </a:defPPr>
           </a:lstStyle>
           <a:p xmlns:a="http://schemas.openxmlformats.org/drawingml/2006/main">
             <a:pPr>
-              <a:defRPr sz="1650" b="1">
-                <a:solidFill>
-                  <a:srgbClr val="245345"/>
+              <a:defRPr sz="1575" b="1">
+                <a:solidFill>
+                  <a:srgbClr val="153F35"/>
                 </a:solidFill>
               </a:defRPr>
             </a:pPr>
             <a:r>
-              <a:rPr sz="1650" b="1">
-                <a:solidFill>
-                  <a:srgbClr val="245345"/>
+              <a:rPr sz="1575" b="1">
+                <a:solidFill>
+                  <a:srgbClr val="153F35"/>
                 </a:solidFill>
               </a:rPr>
-              <a:t>•</a:t>
+              <a:t>Signal</a:t>
             </a:r>
           </a:p>
         </p:txBody>
       </p:sp>
       <p:sp>
         <p:nvSpPr>
-          <p:cNvPr id="9" name="">
-            <a:extLst xmlns:a="http://schemas.openxmlformats.org/drawingml/2006/main">
-              <a:ext uri="{FF2B5EF4-FFF2-40B4-BE49-F238E27FC236}">
-                <a16:creationId xmlns:a16="http://schemas.microsoft.com/office/drawing/2014/main" id="{3A5989D1-7819-410B-925A-11F8FBF5F5A5}"/>
+          <p:cNvPr id="12" name="">
+            <a:extLst xmlns:a="http://schemas.openxmlformats.org/drawingml/2006/main">
+              <a:ext uri="{FF2B5EF4-FFF2-40B4-BE49-F238E27FC236}">
+                <a16:creationId xmlns:a16="http://schemas.microsoft.com/office/drawing/2014/main" id="{6B480415-5F1E-4CAC-967D-CD821B605572}"/>
               </a:ext>
             </a:extLst>
           </p:cNvPr>
@@ -5021,8 +5187,8 @@
         </p:nvSpPr>
         <p:spPr>
           <a:xfrm xmlns:a="http://schemas.openxmlformats.org/drawingml/2006/main">
-            <a:off x="1181100" y="3371850"/>
-            <a:ext cx="9486900" cy="361950"/>
+            <a:off x="8401050" y="2590800"/>
+            <a:ext cx="2819400" cy="1428750"/>
           </a:xfrm>
           <a:prstGeom xmlns:a="http://schemas.openxmlformats.org/drawingml/2006/main" prst="rect">
             <a:avLst/>
@@ -5037,7 +5203,7 @@
           <a:bodyPr xmlns:a="http://schemas.openxmlformats.org/drawingml/2006/main"/>
           <a:lstStyle xmlns:a="http://schemas.openxmlformats.org/drawingml/2006/main">
             <a:defPPr>
-              <a:defRPr sz="1650" b="0">
+              <a:defRPr sz="1275" b="0">
                 <a:solidFill>
                   <a:srgbClr val="202624"/>
                 </a:solidFill>
@@ -5046,29 +5212,29 @@
           </a:lstStyle>
           <a:p xmlns:a="http://schemas.openxmlformats.org/drawingml/2006/main">
             <a:pPr>
-              <a:defRPr sz="1650" b="0">
+              <a:defRPr sz="1275" b="0">
                 <a:solidFill>
                   <a:srgbClr val="202624"/>
                 </a:solidFill>
               </a:defRPr>
             </a:pPr>
             <a:r>
-              <a:rPr sz="1650" b="0">
+              <a:rPr sz="1275" b="0">
                 <a:solidFill>
                   <a:srgbClr val="202624"/>
                 </a:solidFill>
               </a:rPr>
-              <a:t>Create tickets for severe themes such as stranded, stale GPS, OTP missing, wrong pickup, and server error.</a:t>
+              <a:t>1-star share was 27.7%, up 2.6 points. Top 1-star versions were 12.19.0 and 12.18.1.</a:t>
             </a:r>
           </a:p>
         </p:txBody>
       </p:sp>
       <p:sp>
         <p:nvSpPr>
-          <p:cNvPr id="10" name="">
-            <a:extLst xmlns:a="http://schemas.openxmlformats.org/drawingml/2006/main">
-              <a:ext uri="{FF2B5EF4-FFF2-40B4-BE49-F238E27FC236}">
-                <a16:creationId xmlns:a16="http://schemas.microsoft.com/office/drawing/2014/main" id="{D0BF04A6-4695-4B42-AB4B-329FD5F64498}"/>
+          <p:cNvPr id="13" name="">
+            <a:extLst xmlns:a="http://schemas.openxmlformats.org/drawingml/2006/main">
+              <a:ext uri="{FF2B5EF4-FFF2-40B4-BE49-F238E27FC236}">
+                <a16:creationId xmlns:a16="http://schemas.microsoft.com/office/drawing/2014/main" id="{BB1D7D2E-4EA0-4440-AD3D-17B2F801825F}"/>
               </a:ext>
             </a:extLst>
           </p:cNvPr>
@@ -5079,8 +5245,8 @@
         </p:nvSpPr>
         <p:spPr>
           <a:xfrm xmlns:a="http://schemas.openxmlformats.org/drawingml/2006/main">
-            <a:off x="857250" y="4057650"/>
-            <a:ext cx="228600" cy="266700"/>
+            <a:off x="857250" y="4953000"/>
+            <a:ext cx="9715500" cy="552450"/>
           </a:xfrm>
           <a:prstGeom xmlns:a="http://schemas.openxmlformats.org/drawingml/2006/main" prst="rect">
             <a:avLst/>
@@ -5095,86 +5261,28 @@
           <a:bodyPr xmlns:a="http://schemas.openxmlformats.org/drawingml/2006/main"/>
           <a:lstStyle xmlns:a="http://schemas.openxmlformats.org/drawingml/2006/main">
             <a:defPPr>
-              <a:defRPr sz="1650" b="1">
-                <a:solidFill>
-                  <a:srgbClr val="245345"/>
+              <a:defRPr sz="1725" b="1">
+                <a:solidFill>
+                  <a:srgbClr val="153F35"/>
                 </a:solidFill>
               </a:defRPr>
             </a:defPPr>
           </a:lstStyle>
           <a:p xmlns:a="http://schemas.openxmlformats.org/drawingml/2006/main">
             <a:pPr>
-              <a:defRPr sz="1650" b="1">
-                <a:solidFill>
-                  <a:srgbClr val="245345"/>
+              <a:defRPr sz="1725" b="1">
+                <a:solidFill>
+                  <a:srgbClr val="153F35"/>
                 </a:solidFill>
               </a:defRPr>
             </a:pPr>
             <a:r>
-              <a:rPr sz="1650" b="1">
-                <a:solidFill>
-                  <a:srgbClr val="245345"/>
+              <a:rPr sz="1725" b="1">
+                <a:solidFill>
+                  <a:srgbClr val="153F35"/>
                 </a:solidFill>
               </a:rPr>
-              <a:t>•</a:t>
-            </a:r>
-          </a:p>
-        </p:txBody>
-      </p:sp>
-      <p:sp>
-        <p:nvSpPr>
-          <p:cNvPr id="11" name="">
-            <a:extLst xmlns:a="http://schemas.openxmlformats.org/drawingml/2006/main">
-              <a:ext uri="{FF2B5EF4-FFF2-40B4-BE49-F238E27FC236}">
-                <a16:creationId xmlns:a16="http://schemas.microsoft.com/office/drawing/2014/main" id="{D4CFD7E8-85E2-4190-BDF8-473E01C2DDD8}"/>
-              </a:ext>
-            </a:extLst>
-          </p:cNvPr>
-          <p:cNvSpPr>
-            <a:spLocks xmlns:a="http://schemas.openxmlformats.org/drawingml/2006/main" noGrp="1"/>
-          </p:cNvSpPr>
-          <p:nvPr/>
-        </p:nvSpPr>
-        <p:spPr>
-          <a:xfrm xmlns:a="http://schemas.openxmlformats.org/drawingml/2006/main">
-            <a:off x="1181100" y="4057650"/>
-            <a:ext cx="9486900" cy="361950"/>
-          </a:xfrm>
-          <a:prstGeom xmlns:a="http://schemas.openxmlformats.org/drawingml/2006/main" prst="rect">
-            <a:avLst/>
-          </a:prstGeom>
-          <a:noFill xmlns:a="http://schemas.openxmlformats.org/drawingml/2006/main"/>
-          <a:ln xmlns:a="http://schemas.openxmlformats.org/drawingml/2006/main" w="0">
-            <a:noFill/>
-            <a:prstDash val="solid"/>
-          </a:ln>
-        </p:spPr>
-        <p:txBody>
-          <a:bodyPr xmlns:a="http://schemas.openxmlformats.org/drawingml/2006/main"/>
-          <a:lstStyle xmlns:a="http://schemas.openxmlformats.org/drawingml/2006/main">
-            <a:defPPr>
-              <a:defRPr sz="1650" b="0">
-                <a:solidFill>
-                  <a:srgbClr val="202624"/>
-                </a:solidFill>
-              </a:defRPr>
-            </a:defPPr>
-          </a:lstStyle>
-          <a:p xmlns:a="http://schemas.openxmlformats.org/drawingml/2006/main">
-            <a:pPr>
-              <a:defRPr sz="1650" b="0">
-                <a:solidFill>
-                  <a:srgbClr val="202624"/>
-                </a:solidFill>
-              </a:defRPr>
-            </a:pPr>
-            <a:r>
-              <a:rPr sz="1650" b="0">
-                <a:solidFill>
-                  <a:srgbClr val="202624"/>
-                </a:solidFill>
-              </a:rPr>
-              <a:t>Run a weekly review with Product, Engineering, Ops, and Customer Success using a weighted pain score.</a:t>
+              <a:t>The script is a small but real starting point for Ratings Room, with a saved JSON snapshot in the repo.</a:t>
             </a:r>
           </a:p>
         </p:txBody>
@@ -5182,7 +5290,7 @@
     </p:spTree>
     <p:extLst>
       <p:ext uri="{BB962C8B-B14F-4D97-AF65-F5344CB8AC3E}">
-        <p14:creationId xmlns:p14="http://schemas.microsoft.com/office/powerpoint/2010/main" val="883576277"/>
+        <p14:creationId xmlns:p14="http://schemas.microsoft.com/office/powerpoint/2010/main" val="1442761120"/>
       </p:ext>
     </p:extLst>
   </p:cSld>
@@ -5213,7 +5321,7 @@
           <p:cNvPr id="14" name="">
             <a:extLst xmlns:a="http://schemas.openxmlformats.org/drawingml/2006/main">
               <a:ext uri="{FF2B5EF4-FFF2-40B4-BE49-F238E27FC236}">
-                <a16:creationId xmlns:a16="http://schemas.microsoft.com/office/drawing/2014/main" id="{EED58787-F46D-4F87-A011-6961CF94F1F8}"/>
+                <a16:creationId xmlns:a16="http://schemas.microsoft.com/office/drawing/2014/main" id="{4AC1A037-1C9C-4A12-A932-1387735495DF}"/>
               </a:ext>
             </a:extLst>
           </p:cNvPr>
@@ -5271,7 +5379,7 @@
           <p:cNvPr id="2" name="">
             <a:extLst xmlns:a="http://schemas.openxmlformats.org/drawingml/2006/main">
               <a:ext uri="{FF2B5EF4-FFF2-40B4-BE49-F238E27FC236}">
-                <a16:creationId xmlns:a16="http://schemas.microsoft.com/office/drawing/2014/main" id="{90B45FAB-FC2D-445C-BC31-0A0599E2D64F}"/>
+                <a16:creationId xmlns:a16="http://schemas.microsoft.com/office/drawing/2014/main" id="{97E3EDDA-5CEE-4F62-9ADE-4AC506E81A06}"/>
               </a:ext>
             </a:extLst>
           </p:cNvPr>
@@ -5319,7 +5427,7 @@
                   <a:srgbClr val="153F35"/>
                 </a:solidFill>
               </a:rPr>
-              <a:t>30/60/90-day execution plan</a:t>
+              <a:t>Ratings Room operating system</a:t>
             </a:r>
           </a:p>
         </p:txBody>
@@ -5329,7 +5437,7 @@
           <p:cNvPr id="3" name="">
             <a:extLst xmlns:a="http://schemas.openxmlformats.org/drawingml/2006/main">
               <a:ext uri="{FF2B5EF4-FFF2-40B4-BE49-F238E27FC236}">
-                <a16:creationId xmlns:a16="http://schemas.microsoft.com/office/drawing/2014/main" id="{31D6E11A-D64D-4270-96B8-CB1D77C22B34}"/>
+                <a16:creationId xmlns:a16="http://schemas.microsoft.com/office/drawing/2014/main" id="{A494DC26-62B2-47F7-8BFD-B9A1F7ECFB24}"/>
               </a:ext>
             </a:extLst>
           </p:cNvPr>
@@ -5362,7 +5470,765 @@
           <p:cNvPr id="4" name="">
             <a:extLst xmlns:a="http://schemas.openxmlformats.org/drawingml/2006/main">
               <a:ext uri="{FF2B5EF4-FFF2-40B4-BE49-F238E27FC236}">
-                <a16:creationId xmlns:a16="http://schemas.microsoft.com/office/drawing/2014/main" id="{ABA96757-ABA1-4E64-A40A-1E0CC73F71A4}"/>
+                <a16:creationId xmlns:a16="http://schemas.microsoft.com/office/drawing/2014/main" id="{F42AD223-C957-41B9-B48D-2490B8453386}"/>
+              </a:ext>
+            </a:extLst>
+          </p:cNvPr>
+          <p:cNvSpPr>
+            <a:spLocks xmlns:a="http://schemas.openxmlformats.org/drawingml/2006/main" noGrp="1"/>
+          </p:cNvSpPr>
+          <p:nvPr/>
+        </p:nvSpPr>
+        <p:spPr>
+          <a:xfrm xmlns:a="http://schemas.openxmlformats.org/drawingml/2006/main">
+            <a:off x="857250" y="1905000"/>
+            <a:ext cx="228600" cy="266700"/>
+          </a:xfrm>
+          <a:prstGeom xmlns:a="http://schemas.openxmlformats.org/drawingml/2006/main" prst="rect">
+            <a:avLst/>
+          </a:prstGeom>
+          <a:noFill xmlns:a="http://schemas.openxmlformats.org/drawingml/2006/main"/>
+          <a:ln xmlns:a="http://schemas.openxmlformats.org/drawingml/2006/main" w="0">
+            <a:noFill/>
+            <a:prstDash val="solid"/>
+          </a:ln>
+        </p:spPr>
+        <p:txBody>
+          <a:bodyPr xmlns:a="http://schemas.openxmlformats.org/drawingml/2006/main"/>
+          <a:lstStyle xmlns:a="http://schemas.openxmlformats.org/drawingml/2006/main">
+            <a:defPPr>
+              <a:defRPr sz="1575" b="1">
+                <a:solidFill>
+                  <a:srgbClr val="245345"/>
+                </a:solidFill>
+              </a:defRPr>
+            </a:defPPr>
+          </a:lstStyle>
+          <a:p xmlns:a="http://schemas.openxmlformats.org/drawingml/2006/main">
+            <a:pPr>
+              <a:defRPr sz="1575" b="1">
+                <a:solidFill>
+                  <a:srgbClr val="245345"/>
+                </a:solidFill>
+              </a:defRPr>
+            </a:pPr>
+            <a:r>
+              <a:rPr sz="1575" b="1">
+                <a:solidFill>
+                  <a:srgbClr val="245345"/>
+                </a:solidFill>
+              </a:rPr>
+              <a:t>•</a:t>
+            </a:r>
+          </a:p>
+        </p:txBody>
+      </p:sp>
+      <p:sp>
+        <p:nvSpPr>
+          <p:cNvPr id="5" name="">
+            <a:extLst xmlns:a="http://schemas.openxmlformats.org/drawingml/2006/main">
+              <a:ext uri="{FF2B5EF4-FFF2-40B4-BE49-F238E27FC236}">
+                <a16:creationId xmlns:a16="http://schemas.microsoft.com/office/drawing/2014/main" id="{03B44C43-CAF8-4395-A654-3E2C041B5617}"/>
+              </a:ext>
+            </a:extLst>
+          </p:cNvPr>
+          <p:cNvSpPr>
+            <a:spLocks xmlns:a="http://schemas.openxmlformats.org/drawingml/2006/main" noGrp="1"/>
+          </p:cNvSpPr>
+          <p:nvPr/>
+        </p:nvSpPr>
+        <p:spPr>
+          <a:xfrm xmlns:a="http://schemas.openxmlformats.org/drawingml/2006/main">
+            <a:off x="1181100" y="1905000"/>
+            <a:ext cx="9486900" cy="361950"/>
+          </a:xfrm>
+          <a:prstGeom xmlns:a="http://schemas.openxmlformats.org/drawingml/2006/main" prst="rect">
+            <a:avLst/>
+          </a:prstGeom>
+          <a:noFill xmlns:a="http://schemas.openxmlformats.org/drawingml/2006/main"/>
+          <a:ln xmlns:a="http://schemas.openxmlformats.org/drawingml/2006/main" w="0">
+            <a:noFill/>
+            <a:prstDash val="solid"/>
+          </a:ln>
+        </p:spPr>
+        <p:txBody>
+          <a:bodyPr xmlns:a="http://schemas.openxmlformats.org/drawingml/2006/main"/>
+          <a:lstStyle xmlns:a="http://schemas.openxmlformats.org/drawingml/2006/main">
+            <a:defPPr>
+              <a:defRPr sz="1575" b="0">
+                <a:solidFill>
+                  <a:srgbClr val="202624"/>
+                </a:solidFill>
+              </a:defRPr>
+            </a:defPPr>
+          </a:lstStyle>
+          <a:p xmlns:a="http://schemas.openxmlformats.org/drawingml/2006/main">
+            <a:pPr>
+              <a:defRPr sz="1575" b="0">
+                <a:solidFill>
+                  <a:srgbClr val="202624"/>
+                </a:solidFill>
+              </a:defRPr>
+            </a:pPr>
+            <a:r>
+              <a:rPr sz="1575" b="0">
+                <a:solidFill>
+                  <a:srgbClr val="202624"/>
+                </a:solidFill>
+              </a:rPr>
+              <a:t>Ingest Play reviews, ratings, app version, device data, developer replies, and internal trip telemetry.</a:t>
+            </a:r>
+          </a:p>
+        </p:txBody>
+      </p:sp>
+      <p:sp>
+        <p:nvSpPr>
+          <p:cNvPr id="6" name="">
+            <a:extLst xmlns:a="http://schemas.openxmlformats.org/drawingml/2006/main">
+              <a:ext uri="{FF2B5EF4-FFF2-40B4-BE49-F238E27FC236}">
+                <a16:creationId xmlns:a16="http://schemas.microsoft.com/office/drawing/2014/main" id="{293097A7-3B17-4BDC-90EA-A854249CA15A}"/>
+              </a:ext>
+            </a:extLst>
+          </p:cNvPr>
+          <p:cNvSpPr>
+            <a:spLocks xmlns:a="http://schemas.openxmlformats.org/drawingml/2006/main" noGrp="1"/>
+          </p:cNvSpPr>
+          <p:nvPr/>
+        </p:nvSpPr>
+        <p:spPr>
+          <a:xfrm xmlns:a="http://schemas.openxmlformats.org/drawingml/2006/main">
+            <a:off x="857250" y="2457450"/>
+            <a:ext cx="228600" cy="266700"/>
+          </a:xfrm>
+          <a:prstGeom xmlns:a="http://schemas.openxmlformats.org/drawingml/2006/main" prst="rect">
+            <a:avLst/>
+          </a:prstGeom>
+          <a:noFill xmlns:a="http://schemas.openxmlformats.org/drawingml/2006/main"/>
+          <a:ln xmlns:a="http://schemas.openxmlformats.org/drawingml/2006/main" w="0">
+            <a:noFill/>
+            <a:prstDash val="solid"/>
+          </a:ln>
+        </p:spPr>
+        <p:txBody>
+          <a:bodyPr xmlns:a="http://schemas.openxmlformats.org/drawingml/2006/main"/>
+          <a:lstStyle xmlns:a="http://schemas.openxmlformats.org/drawingml/2006/main">
+            <a:defPPr>
+              <a:defRPr sz="1575" b="1">
+                <a:solidFill>
+                  <a:srgbClr val="245345"/>
+                </a:solidFill>
+              </a:defRPr>
+            </a:defPPr>
+          </a:lstStyle>
+          <a:p xmlns:a="http://schemas.openxmlformats.org/drawingml/2006/main">
+            <a:pPr>
+              <a:defRPr sz="1575" b="1">
+                <a:solidFill>
+                  <a:srgbClr val="245345"/>
+                </a:solidFill>
+              </a:defRPr>
+            </a:pPr>
+            <a:r>
+              <a:rPr sz="1575" b="1">
+                <a:solidFill>
+                  <a:srgbClr val="245345"/>
+                </a:solidFill>
+              </a:rPr>
+              <a:t>•</a:t>
+            </a:r>
+          </a:p>
+        </p:txBody>
+      </p:sp>
+      <p:sp>
+        <p:nvSpPr>
+          <p:cNvPr id="7" name="">
+            <a:extLst xmlns:a="http://schemas.openxmlformats.org/drawingml/2006/main">
+              <a:ext uri="{FF2B5EF4-FFF2-40B4-BE49-F238E27FC236}">
+                <a16:creationId xmlns:a16="http://schemas.microsoft.com/office/drawing/2014/main" id="{A0007A6C-2755-420B-B6E1-2485FDAAC4FB}"/>
+              </a:ext>
+            </a:extLst>
+          </p:cNvPr>
+          <p:cNvSpPr>
+            <a:spLocks xmlns:a="http://schemas.openxmlformats.org/drawingml/2006/main" noGrp="1"/>
+          </p:cNvSpPr>
+          <p:nvPr/>
+        </p:nvSpPr>
+        <p:spPr>
+          <a:xfrm xmlns:a="http://schemas.openxmlformats.org/drawingml/2006/main">
+            <a:off x="1181100" y="2457450"/>
+            <a:ext cx="9486900" cy="361950"/>
+          </a:xfrm>
+          <a:prstGeom xmlns:a="http://schemas.openxmlformats.org/drawingml/2006/main" prst="rect">
+            <a:avLst/>
+          </a:prstGeom>
+          <a:noFill xmlns:a="http://schemas.openxmlformats.org/drawingml/2006/main"/>
+          <a:ln xmlns:a="http://schemas.openxmlformats.org/drawingml/2006/main" w="0">
+            <a:noFill/>
+            <a:prstDash val="solid"/>
+          </a:ln>
+        </p:spPr>
+        <p:txBody>
+          <a:bodyPr xmlns:a="http://schemas.openxmlformats.org/drawingml/2006/main"/>
+          <a:lstStyle xmlns:a="http://schemas.openxmlformats.org/drawingml/2006/main">
+            <a:defPPr>
+              <a:defRPr sz="1575" b="0">
+                <a:solidFill>
+                  <a:srgbClr val="202624"/>
+                </a:solidFill>
+              </a:defRPr>
+            </a:defPPr>
+          </a:lstStyle>
+          <a:p xmlns:a="http://schemas.openxmlformats.org/drawingml/2006/main">
+            <a:pPr>
+              <a:defRPr sz="1575" b="0">
+                <a:solidFill>
+                  <a:srgbClr val="202624"/>
+                </a:solidFill>
+              </a:defRPr>
+            </a:pPr>
+            <a:r>
+              <a:rPr sz="1575" b="0">
+                <a:solidFill>
+                  <a:srgbClr val="202624"/>
+                </a:solidFill>
+              </a:rPr>
+              <a:t>Tag every review by trip stage, product theme, severity, owner, and recovery status.</a:t>
+            </a:r>
+          </a:p>
+        </p:txBody>
+      </p:sp>
+      <p:sp>
+        <p:nvSpPr>
+          <p:cNvPr id="8" name="">
+            <a:extLst xmlns:a="http://schemas.openxmlformats.org/drawingml/2006/main">
+              <a:ext uri="{FF2B5EF4-FFF2-40B4-BE49-F238E27FC236}">
+                <a16:creationId xmlns:a16="http://schemas.microsoft.com/office/drawing/2014/main" id="{87ABF68D-409D-4212-8328-D53154ED3E26}"/>
+              </a:ext>
+            </a:extLst>
+          </p:cNvPr>
+          <p:cNvSpPr>
+            <a:spLocks xmlns:a="http://schemas.openxmlformats.org/drawingml/2006/main" noGrp="1"/>
+          </p:cNvSpPr>
+          <p:nvPr/>
+        </p:nvSpPr>
+        <p:spPr>
+          <a:xfrm xmlns:a="http://schemas.openxmlformats.org/drawingml/2006/main">
+            <a:off x="857250" y="3009900"/>
+            <a:ext cx="228600" cy="266700"/>
+          </a:xfrm>
+          <a:prstGeom xmlns:a="http://schemas.openxmlformats.org/drawingml/2006/main" prst="rect">
+            <a:avLst/>
+          </a:prstGeom>
+          <a:noFill xmlns:a="http://schemas.openxmlformats.org/drawingml/2006/main"/>
+          <a:ln xmlns:a="http://schemas.openxmlformats.org/drawingml/2006/main" w="0">
+            <a:noFill/>
+            <a:prstDash val="solid"/>
+          </a:ln>
+        </p:spPr>
+        <p:txBody>
+          <a:bodyPr xmlns:a="http://schemas.openxmlformats.org/drawingml/2006/main"/>
+          <a:lstStyle xmlns:a="http://schemas.openxmlformats.org/drawingml/2006/main">
+            <a:defPPr>
+              <a:defRPr sz="1575" b="1">
+                <a:solidFill>
+                  <a:srgbClr val="245345"/>
+                </a:solidFill>
+              </a:defRPr>
+            </a:defPPr>
+          </a:lstStyle>
+          <a:p xmlns:a="http://schemas.openxmlformats.org/drawingml/2006/main">
+            <a:pPr>
+              <a:defRPr sz="1575" b="1">
+                <a:solidFill>
+                  <a:srgbClr val="245345"/>
+                </a:solidFill>
+              </a:defRPr>
+            </a:pPr>
+            <a:r>
+              <a:rPr sz="1575" b="1">
+                <a:solidFill>
+                  <a:srgbClr val="245345"/>
+                </a:solidFill>
+              </a:rPr>
+              <a:t>•</a:t>
+            </a:r>
+          </a:p>
+        </p:txBody>
+      </p:sp>
+      <p:sp>
+        <p:nvSpPr>
+          <p:cNvPr id="9" name="">
+            <a:extLst xmlns:a="http://schemas.openxmlformats.org/drawingml/2006/main">
+              <a:ext uri="{FF2B5EF4-FFF2-40B4-BE49-F238E27FC236}">
+                <a16:creationId xmlns:a16="http://schemas.microsoft.com/office/drawing/2014/main" id="{847B4427-ED7C-46FF-973B-7BF6907541AD}"/>
+              </a:ext>
+            </a:extLst>
+          </p:cNvPr>
+          <p:cNvSpPr>
+            <a:spLocks xmlns:a="http://schemas.openxmlformats.org/drawingml/2006/main" noGrp="1"/>
+          </p:cNvSpPr>
+          <p:nvPr/>
+        </p:nvSpPr>
+        <p:spPr>
+          <a:xfrm xmlns:a="http://schemas.openxmlformats.org/drawingml/2006/main">
+            <a:off x="1181100" y="3009900"/>
+            <a:ext cx="9486900" cy="361950"/>
+          </a:xfrm>
+          <a:prstGeom xmlns:a="http://schemas.openxmlformats.org/drawingml/2006/main" prst="rect">
+            <a:avLst/>
+          </a:prstGeom>
+          <a:noFill xmlns:a="http://schemas.openxmlformats.org/drawingml/2006/main"/>
+          <a:ln xmlns:a="http://schemas.openxmlformats.org/drawingml/2006/main" w="0">
+            <a:noFill/>
+            <a:prstDash val="solid"/>
+          </a:ln>
+        </p:spPr>
+        <p:txBody>
+          <a:bodyPr xmlns:a="http://schemas.openxmlformats.org/drawingml/2006/main"/>
+          <a:lstStyle xmlns:a="http://schemas.openxmlformats.org/drawingml/2006/main">
+            <a:defPPr>
+              <a:defRPr sz="1575" b="0">
+                <a:solidFill>
+                  <a:srgbClr val="202624"/>
+                </a:solidFill>
+              </a:defRPr>
+            </a:defPPr>
+          </a:lstStyle>
+          <a:p xmlns:a="http://schemas.openxmlformats.org/drawingml/2006/main">
+            <a:pPr>
+              <a:defRPr sz="1575" b="0">
+                <a:solidFill>
+                  <a:srgbClr val="202624"/>
+                </a:solidFill>
+              </a:defRPr>
+            </a:pPr>
+            <a:r>
+              <a:rPr sz="1575" b="0">
+                <a:solidFill>
+                  <a:srgbClr val="202624"/>
+                </a:solidFill>
+              </a:rPr>
+              <a:t>Create tickets for severe themes such as stranded, stale GPS, OTP missing, wrong pickup, and server error.</a:t>
+            </a:r>
+          </a:p>
+        </p:txBody>
+      </p:sp>
+      <p:sp>
+        <p:nvSpPr>
+          <p:cNvPr id="10" name="">
+            <a:extLst xmlns:a="http://schemas.openxmlformats.org/drawingml/2006/main">
+              <a:ext uri="{FF2B5EF4-FFF2-40B4-BE49-F238E27FC236}">
+                <a16:creationId xmlns:a16="http://schemas.microsoft.com/office/drawing/2014/main" id="{D81E68AC-9D75-49F2-92F8-81A83EB9E7DF}"/>
+              </a:ext>
+            </a:extLst>
+          </p:cNvPr>
+          <p:cNvSpPr>
+            <a:spLocks xmlns:a="http://schemas.openxmlformats.org/drawingml/2006/main" noGrp="1"/>
+          </p:cNvSpPr>
+          <p:nvPr/>
+        </p:nvSpPr>
+        <p:spPr>
+          <a:xfrm xmlns:a="http://schemas.openxmlformats.org/drawingml/2006/main">
+            <a:off x="857250" y="3562350"/>
+            <a:ext cx="228600" cy="266700"/>
+          </a:xfrm>
+          <a:prstGeom xmlns:a="http://schemas.openxmlformats.org/drawingml/2006/main" prst="rect">
+            <a:avLst/>
+          </a:prstGeom>
+          <a:noFill xmlns:a="http://schemas.openxmlformats.org/drawingml/2006/main"/>
+          <a:ln xmlns:a="http://schemas.openxmlformats.org/drawingml/2006/main" w="0">
+            <a:noFill/>
+            <a:prstDash val="solid"/>
+          </a:ln>
+        </p:spPr>
+        <p:txBody>
+          <a:bodyPr xmlns:a="http://schemas.openxmlformats.org/drawingml/2006/main"/>
+          <a:lstStyle xmlns:a="http://schemas.openxmlformats.org/drawingml/2006/main">
+            <a:defPPr>
+              <a:defRPr sz="1575" b="1">
+                <a:solidFill>
+                  <a:srgbClr val="245345"/>
+                </a:solidFill>
+              </a:defRPr>
+            </a:defPPr>
+          </a:lstStyle>
+          <a:p xmlns:a="http://schemas.openxmlformats.org/drawingml/2006/main">
+            <a:pPr>
+              <a:defRPr sz="1575" b="1">
+                <a:solidFill>
+                  <a:srgbClr val="245345"/>
+                </a:solidFill>
+              </a:defRPr>
+            </a:pPr>
+            <a:r>
+              <a:rPr sz="1575" b="1">
+                <a:solidFill>
+                  <a:srgbClr val="245345"/>
+                </a:solidFill>
+              </a:rPr>
+              <a:t>•</a:t>
+            </a:r>
+          </a:p>
+        </p:txBody>
+      </p:sp>
+      <p:sp>
+        <p:nvSpPr>
+          <p:cNvPr id="11" name="">
+            <a:extLst xmlns:a="http://schemas.openxmlformats.org/drawingml/2006/main">
+              <a:ext uri="{FF2B5EF4-FFF2-40B4-BE49-F238E27FC236}">
+                <a16:creationId xmlns:a16="http://schemas.microsoft.com/office/drawing/2014/main" id="{BACD568E-AF67-4EAF-939E-41F4E131CAC4}"/>
+              </a:ext>
+            </a:extLst>
+          </p:cNvPr>
+          <p:cNvSpPr>
+            <a:spLocks xmlns:a="http://schemas.openxmlformats.org/drawingml/2006/main" noGrp="1"/>
+          </p:cNvSpPr>
+          <p:nvPr/>
+        </p:nvSpPr>
+        <p:spPr>
+          <a:xfrm xmlns:a="http://schemas.openxmlformats.org/drawingml/2006/main">
+            <a:off x="1181100" y="3562350"/>
+            <a:ext cx="9486900" cy="361950"/>
+          </a:xfrm>
+          <a:prstGeom xmlns:a="http://schemas.openxmlformats.org/drawingml/2006/main" prst="rect">
+            <a:avLst/>
+          </a:prstGeom>
+          <a:noFill xmlns:a="http://schemas.openxmlformats.org/drawingml/2006/main"/>
+          <a:ln xmlns:a="http://schemas.openxmlformats.org/drawingml/2006/main" w="0">
+            <a:noFill/>
+            <a:prstDash val="solid"/>
+          </a:ln>
+        </p:spPr>
+        <p:txBody>
+          <a:bodyPr xmlns:a="http://schemas.openxmlformats.org/drawingml/2006/main"/>
+          <a:lstStyle xmlns:a="http://schemas.openxmlformats.org/drawingml/2006/main">
+            <a:defPPr>
+              <a:defRPr sz="1575" b="0">
+                <a:solidFill>
+                  <a:srgbClr val="202624"/>
+                </a:solidFill>
+              </a:defRPr>
+            </a:defPPr>
+          </a:lstStyle>
+          <a:p xmlns:a="http://schemas.openxmlformats.org/drawingml/2006/main">
+            <a:pPr>
+              <a:defRPr sz="1575" b="0">
+                <a:solidFill>
+                  <a:srgbClr val="202624"/>
+                </a:solidFill>
+              </a:defRPr>
+            </a:pPr>
+            <a:r>
+              <a:rPr sz="1575" b="0">
+                <a:solidFill>
+                  <a:srgbClr val="202624"/>
+                </a:solidFill>
+              </a:rPr>
+              <a:t>Audit no-show geofence/timer settings by client before assuming the product flow is the only gap.</a:t>
+            </a:r>
+          </a:p>
+        </p:txBody>
+      </p:sp>
+      <p:sp>
+        <p:nvSpPr>
+          <p:cNvPr id="12" name="">
+            <a:extLst xmlns:a="http://schemas.openxmlformats.org/drawingml/2006/main">
+              <a:ext uri="{FF2B5EF4-FFF2-40B4-BE49-F238E27FC236}">
+                <a16:creationId xmlns:a16="http://schemas.microsoft.com/office/drawing/2014/main" id="{C5B1C058-F88E-4D8C-80C4-8CB4EDFFD1D1}"/>
+              </a:ext>
+            </a:extLst>
+          </p:cNvPr>
+          <p:cNvSpPr>
+            <a:spLocks xmlns:a="http://schemas.openxmlformats.org/drawingml/2006/main" noGrp="1"/>
+          </p:cNvSpPr>
+          <p:nvPr/>
+        </p:nvSpPr>
+        <p:spPr>
+          <a:xfrm xmlns:a="http://schemas.openxmlformats.org/drawingml/2006/main">
+            <a:off x="857250" y="4114800"/>
+            <a:ext cx="228600" cy="266700"/>
+          </a:xfrm>
+          <a:prstGeom xmlns:a="http://schemas.openxmlformats.org/drawingml/2006/main" prst="rect">
+            <a:avLst/>
+          </a:prstGeom>
+          <a:noFill xmlns:a="http://schemas.openxmlformats.org/drawingml/2006/main"/>
+          <a:ln xmlns:a="http://schemas.openxmlformats.org/drawingml/2006/main" w="0">
+            <a:noFill/>
+            <a:prstDash val="solid"/>
+          </a:ln>
+        </p:spPr>
+        <p:txBody>
+          <a:bodyPr xmlns:a="http://schemas.openxmlformats.org/drawingml/2006/main"/>
+          <a:lstStyle xmlns:a="http://schemas.openxmlformats.org/drawingml/2006/main">
+            <a:defPPr>
+              <a:defRPr sz="1575" b="1">
+                <a:solidFill>
+                  <a:srgbClr val="245345"/>
+                </a:solidFill>
+              </a:defRPr>
+            </a:defPPr>
+          </a:lstStyle>
+          <a:p xmlns:a="http://schemas.openxmlformats.org/drawingml/2006/main">
+            <a:pPr>
+              <a:defRPr sz="1575" b="1">
+                <a:solidFill>
+                  <a:srgbClr val="245345"/>
+                </a:solidFill>
+              </a:defRPr>
+            </a:pPr>
+            <a:r>
+              <a:rPr sz="1575" b="1">
+                <a:solidFill>
+                  <a:srgbClr val="245345"/>
+                </a:solidFill>
+              </a:rPr>
+              <a:t>•</a:t>
+            </a:r>
+          </a:p>
+        </p:txBody>
+      </p:sp>
+      <p:sp>
+        <p:nvSpPr>
+          <p:cNvPr id="13" name="">
+            <a:extLst xmlns:a="http://schemas.openxmlformats.org/drawingml/2006/main">
+              <a:ext uri="{FF2B5EF4-FFF2-40B4-BE49-F238E27FC236}">
+                <a16:creationId xmlns:a16="http://schemas.microsoft.com/office/drawing/2014/main" id="{202C9760-8843-44AF-8261-F46E58617EE2}"/>
+              </a:ext>
+            </a:extLst>
+          </p:cNvPr>
+          <p:cNvSpPr>
+            <a:spLocks xmlns:a="http://schemas.openxmlformats.org/drawingml/2006/main" noGrp="1"/>
+          </p:cNvSpPr>
+          <p:nvPr/>
+        </p:nvSpPr>
+        <p:spPr>
+          <a:xfrm xmlns:a="http://schemas.openxmlformats.org/drawingml/2006/main">
+            <a:off x="1181100" y="4114800"/>
+            <a:ext cx="9486900" cy="361950"/>
+          </a:xfrm>
+          <a:prstGeom xmlns:a="http://schemas.openxmlformats.org/drawingml/2006/main" prst="rect">
+            <a:avLst/>
+          </a:prstGeom>
+          <a:noFill xmlns:a="http://schemas.openxmlformats.org/drawingml/2006/main"/>
+          <a:ln xmlns:a="http://schemas.openxmlformats.org/drawingml/2006/main" w="0">
+            <a:noFill/>
+            <a:prstDash val="solid"/>
+          </a:ln>
+        </p:spPr>
+        <p:txBody>
+          <a:bodyPr xmlns:a="http://schemas.openxmlformats.org/drawingml/2006/main"/>
+          <a:lstStyle xmlns:a="http://schemas.openxmlformats.org/drawingml/2006/main">
+            <a:defPPr>
+              <a:defRPr sz="1575" b="0">
+                <a:solidFill>
+                  <a:srgbClr val="202624"/>
+                </a:solidFill>
+              </a:defRPr>
+            </a:defPPr>
+          </a:lstStyle>
+          <a:p xmlns:a="http://schemas.openxmlformats.org/drawingml/2006/main">
+            <a:pPr>
+              <a:defRPr sz="1575" b="0">
+                <a:solidFill>
+                  <a:srgbClr val="202624"/>
+                </a:solidFill>
+              </a:defRPr>
+            </a:pPr>
+            <a:r>
+              <a:rPr sz="1575" b="0">
+                <a:solidFill>
+                  <a:srgbClr val="202624"/>
+                </a:solidFill>
+              </a:rPr>
+              <a:t>Run staged rollouts with a halt rule when 1-star share or crash/session issues spike.</a:t>
+            </a:r>
+          </a:p>
+        </p:txBody>
+      </p:sp>
+    </p:spTree>
+    <p:extLst>
+      <p:ext uri="{BB962C8B-B14F-4D97-AF65-F5344CB8AC3E}">
+        <p14:creationId xmlns:p14="http://schemas.microsoft.com/office/powerpoint/2010/main" val="966643387"/>
+      </p:ext>
+    </p:extLst>
+  </p:cSld>
+</p:sld>
+</file>
+
+<file path=ppt/slides/slide6.xml><?xml version="1.0" encoding="utf-8"?>
+<p:sld xmlns:p="http://schemas.openxmlformats.org/presentationml/2006/main">
+  <p:cSld>
+    <p:bg>
+      <p:bgPr>
+        <a:solidFill xmlns:a="http://schemas.openxmlformats.org/drawingml/2006/main">
+          <a:srgbClr val="F8FBFA"/>
+        </a:solidFill>
+      </p:bgPr>
+    </p:bg>
+    <p:spTree>
+      <p:nvGrpSpPr>
+        <p:cNvPr id="1" name=""/>
+        <p:cNvGrpSpPr/>
+        <p:nvPr/>
+      </p:nvGrpSpPr>
+      <p:grpSpPr>
+        <a:xfrm xmlns:a="http://schemas.openxmlformats.org/drawingml/2006/main"/>
+      </p:grpSpPr>
+      <p:sp>
+        <p:nvSpPr>
+          <p:cNvPr id="14" name="">
+            <a:extLst xmlns:a="http://schemas.openxmlformats.org/drawingml/2006/main">
+              <a:ext uri="{FF2B5EF4-FFF2-40B4-BE49-F238E27FC236}">
+                <a16:creationId xmlns:a16="http://schemas.microsoft.com/office/drawing/2014/main" id="{8E60E98A-9DF4-473A-B7F6-0FAEA8C0F61D}"/>
+              </a:ext>
+            </a:extLst>
+          </p:cNvPr>
+          <p:cNvSpPr>
+            <a:spLocks xmlns:a="http://schemas.openxmlformats.org/drawingml/2006/main" noGrp="1"/>
+          </p:cNvSpPr>
+          <p:nvPr/>
+        </p:nvSpPr>
+        <p:spPr>
+          <a:xfrm xmlns:a="http://schemas.openxmlformats.org/drawingml/2006/main">
+            <a:off x="666750" y="419100"/>
+            <a:ext cx="3429000" cy="228600"/>
+          </a:xfrm>
+          <a:prstGeom xmlns:a="http://schemas.openxmlformats.org/drawingml/2006/main" prst="rect">
+            <a:avLst/>
+          </a:prstGeom>
+          <a:noFill xmlns:a="http://schemas.openxmlformats.org/drawingml/2006/main"/>
+          <a:ln xmlns:a="http://schemas.openxmlformats.org/drawingml/2006/main" w="0">
+            <a:noFill/>
+            <a:prstDash val="solid"/>
+          </a:ln>
+        </p:spPr>
+        <p:txBody>
+          <a:bodyPr xmlns:a="http://schemas.openxmlformats.org/drawingml/2006/main"/>
+          <a:lstStyle xmlns:a="http://schemas.openxmlformats.org/drawingml/2006/main">
+            <a:defPPr>
+              <a:defRPr sz="975" b="1">
+                <a:solidFill>
+                  <a:srgbClr val="547268"/>
+                </a:solidFill>
+              </a:defRPr>
+            </a:defPPr>
+          </a:lstStyle>
+          <a:p xmlns:a="http://schemas.openxmlformats.org/drawingml/2006/main">
+            <a:pPr>
+              <a:defRPr sz="975" b="1">
+                <a:solidFill>
+                  <a:srgbClr val="547268"/>
+                </a:solidFill>
+              </a:defRPr>
+            </a:pPr>
+            <a:r>
+              <a:rPr sz="975" b="1">
+                <a:solidFill>
+                  <a:srgbClr val="547268"/>
+                </a:solidFill>
+              </a:rPr>
+              <a:t>MOVEINSYNC FDE CASE</a:t>
+            </a:r>
+          </a:p>
+        </p:txBody>
+      </p:sp>
+      <p:sp>
+        <p:nvSpPr>
+          <p:cNvPr id="2" name="">
+            <a:extLst xmlns:a="http://schemas.openxmlformats.org/drawingml/2006/main">
+              <a:ext uri="{FF2B5EF4-FFF2-40B4-BE49-F238E27FC236}">
+                <a16:creationId xmlns:a16="http://schemas.microsoft.com/office/drawing/2014/main" id="{AB101201-D2AF-4593-BED9-8BF52AC4D2A3}"/>
+              </a:ext>
+            </a:extLst>
+          </p:cNvPr>
+          <p:cNvSpPr>
+            <a:spLocks xmlns:a="http://schemas.openxmlformats.org/drawingml/2006/main" noGrp="1"/>
+          </p:cNvSpPr>
+          <p:nvPr/>
+        </p:nvSpPr>
+        <p:spPr>
+          <a:xfrm xmlns:a="http://schemas.openxmlformats.org/drawingml/2006/main">
+            <a:off x="666750" y="800100"/>
+            <a:ext cx="9906000" cy="723900"/>
+          </a:xfrm>
+          <a:prstGeom xmlns:a="http://schemas.openxmlformats.org/drawingml/2006/main" prst="rect">
+            <a:avLst/>
+          </a:prstGeom>
+          <a:noFill xmlns:a="http://schemas.openxmlformats.org/drawingml/2006/main"/>
+          <a:ln xmlns:a="http://schemas.openxmlformats.org/drawingml/2006/main" w="0">
+            <a:noFill/>
+            <a:prstDash val="solid"/>
+          </a:ln>
+        </p:spPr>
+        <p:txBody>
+          <a:bodyPr xmlns:a="http://schemas.openxmlformats.org/drawingml/2006/main"/>
+          <a:lstStyle xmlns:a="http://schemas.openxmlformats.org/drawingml/2006/main">
+            <a:defPPr>
+              <a:defRPr sz="2550" b="1">
+                <a:solidFill>
+                  <a:srgbClr val="153F35"/>
+                </a:solidFill>
+              </a:defRPr>
+            </a:defPPr>
+          </a:lstStyle>
+          <a:p xmlns:a="http://schemas.openxmlformats.org/drawingml/2006/main">
+            <a:pPr>
+              <a:defRPr sz="2550" b="1">
+                <a:solidFill>
+                  <a:srgbClr val="153F35"/>
+                </a:solidFill>
+              </a:defRPr>
+            </a:pPr>
+            <a:r>
+              <a:rPr sz="2550" b="1">
+                <a:solidFill>
+                  <a:srgbClr val="153F35"/>
+                </a:solidFill>
+              </a:rPr>
+              <a:t>30/60/90-day execution plan</a:t>
+            </a:r>
+          </a:p>
+        </p:txBody>
+      </p:sp>
+      <p:sp>
+        <p:nvSpPr>
+          <p:cNvPr id="3" name="">
+            <a:extLst xmlns:a="http://schemas.openxmlformats.org/drawingml/2006/main">
+              <a:ext uri="{FF2B5EF4-FFF2-40B4-BE49-F238E27FC236}">
+                <a16:creationId xmlns:a16="http://schemas.microsoft.com/office/drawing/2014/main" id="{09A86D7F-71D1-4DDF-8358-015D95F5FB70}"/>
+              </a:ext>
+            </a:extLst>
+          </p:cNvPr>
+          <p:cNvSpPr>
+            <a:spLocks xmlns:a="http://schemas.openxmlformats.org/drawingml/2006/main" noGrp="1"/>
+          </p:cNvSpPr>
+          <p:nvPr/>
+        </p:nvSpPr>
+        <p:spPr>
+          <a:xfrm xmlns:a="http://schemas.openxmlformats.org/drawingml/2006/main">
+            <a:off x="666750" y="1524000"/>
+            <a:ext cx="9906000" cy="19050"/>
+          </a:xfrm>
+          <a:prstGeom xmlns:a="http://schemas.openxmlformats.org/drawingml/2006/main" prst="rect">
+            <a:avLst/>
+          </a:prstGeom>
+          <a:solidFill xmlns:a="http://schemas.openxmlformats.org/drawingml/2006/main">
+            <a:srgbClr val="245345"/>
+          </a:solidFill>
+          <a:ln xmlns:a="http://schemas.openxmlformats.org/drawingml/2006/main" w="0">
+            <a:solidFill>
+              <a:srgbClr val="245345"/>
+            </a:solidFill>
+            <a:prstDash val="solid"/>
+          </a:ln>
+        </p:spPr>
+      </p:sp>
+      <p:sp>
+        <p:nvSpPr>
+          <p:cNvPr id="4" name="">
+            <a:extLst xmlns:a="http://schemas.openxmlformats.org/drawingml/2006/main">
+              <a:ext uri="{FF2B5EF4-FFF2-40B4-BE49-F238E27FC236}">
+                <a16:creationId xmlns:a16="http://schemas.microsoft.com/office/drawing/2014/main" id="{30E38292-A0B3-49DA-9600-A760839E7144}"/>
               </a:ext>
             </a:extLst>
           </p:cNvPr>
@@ -5395,7 +6261,7 @@
           <p:cNvPr id="5" name="">
             <a:extLst xmlns:a="http://schemas.openxmlformats.org/drawingml/2006/main">
               <a:ext uri="{FF2B5EF4-FFF2-40B4-BE49-F238E27FC236}">
-                <a16:creationId xmlns:a16="http://schemas.microsoft.com/office/drawing/2014/main" id="{C2556E44-30D6-416E-882B-6A88BB21BBCF}"/>
+                <a16:creationId xmlns:a16="http://schemas.microsoft.com/office/drawing/2014/main" id="{5D8E01A9-C9E4-41E8-91D4-22A07A517A5A}"/>
               </a:ext>
             </a:extLst>
           </p:cNvPr>
@@ -5453,7 +6319,7 @@
           <p:cNvPr id="6" name="">
             <a:extLst xmlns:a="http://schemas.openxmlformats.org/drawingml/2006/main">
               <a:ext uri="{FF2B5EF4-FFF2-40B4-BE49-F238E27FC236}">
-                <a16:creationId xmlns:a16="http://schemas.microsoft.com/office/drawing/2014/main" id="{EB4F5A04-1A1A-4A92-A494-53A587FE3D29}"/>
+                <a16:creationId xmlns:a16="http://schemas.microsoft.com/office/drawing/2014/main" id="{3BD41207-4B53-4E75-9027-F9B890EBF86D}"/>
               </a:ext>
             </a:extLst>
           </p:cNvPr>
@@ -5511,7 +6377,7 @@
           <p:cNvPr id="7" name="">
             <a:extLst xmlns:a="http://schemas.openxmlformats.org/drawingml/2006/main">
               <a:ext uri="{FF2B5EF4-FFF2-40B4-BE49-F238E27FC236}">
-                <a16:creationId xmlns:a16="http://schemas.microsoft.com/office/drawing/2014/main" id="{EF9E7E4A-29ED-41C1-8399-E06EBFA8B371}"/>
+                <a16:creationId xmlns:a16="http://schemas.microsoft.com/office/drawing/2014/main" id="{73015A26-7F09-422C-B974-E37E6B4213AF}"/>
               </a:ext>
             </a:extLst>
           </p:cNvPr>
@@ -5544,7 +6410,7 @@
           <p:cNvPr id="8" name="">
             <a:extLst xmlns:a="http://schemas.openxmlformats.org/drawingml/2006/main">
               <a:ext uri="{FF2B5EF4-FFF2-40B4-BE49-F238E27FC236}">
-                <a16:creationId xmlns:a16="http://schemas.microsoft.com/office/drawing/2014/main" id="{545C550F-5AB3-46DD-92BA-B151B009E312}"/>
+                <a16:creationId xmlns:a16="http://schemas.microsoft.com/office/drawing/2014/main" id="{425CD407-C752-4B21-AA85-1C1F1AD93D3A}"/>
               </a:ext>
             </a:extLst>
           </p:cNvPr>
@@ -5602,7 +6468,7 @@
           <p:cNvPr id="9" name="">
             <a:extLst xmlns:a="http://schemas.openxmlformats.org/drawingml/2006/main">
               <a:ext uri="{FF2B5EF4-FFF2-40B4-BE49-F238E27FC236}">
-                <a16:creationId xmlns:a16="http://schemas.microsoft.com/office/drawing/2014/main" id="{B59B964F-FF8F-4295-8272-0CF551F59D55}"/>
+                <a16:creationId xmlns:a16="http://schemas.microsoft.com/office/drawing/2014/main" id="{AE7EC92C-C935-40BA-BBCA-FC8DE1FC9643}"/>
               </a:ext>
             </a:extLst>
           </p:cNvPr>
@@ -5660,7 +6526,7 @@
           <p:cNvPr id="10" name="">
             <a:extLst xmlns:a="http://schemas.openxmlformats.org/drawingml/2006/main">
               <a:ext uri="{FF2B5EF4-FFF2-40B4-BE49-F238E27FC236}">
-                <a16:creationId xmlns:a16="http://schemas.microsoft.com/office/drawing/2014/main" id="{54FED50A-010D-4B65-81B5-308149C0E200}"/>
+                <a16:creationId xmlns:a16="http://schemas.microsoft.com/office/drawing/2014/main" id="{B7D5B31F-5CA9-4D3A-90AA-A1CC59C9F0BF}"/>
               </a:ext>
             </a:extLst>
           </p:cNvPr>
@@ -5693,7 +6559,7 @@
           <p:cNvPr id="11" name="">
             <a:extLst xmlns:a="http://schemas.openxmlformats.org/drawingml/2006/main">
               <a:ext uri="{FF2B5EF4-FFF2-40B4-BE49-F238E27FC236}">
-                <a16:creationId xmlns:a16="http://schemas.microsoft.com/office/drawing/2014/main" id="{B4A3A21D-2BE9-4CFE-8041-013BA0D73E01}"/>
+                <a16:creationId xmlns:a16="http://schemas.microsoft.com/office/drawing/2014/main" id="{1A93D369-FFE5-42DF-A8F8-8FE26A6D8CAF}"/>
               </a:ext>
             </a:extLst>
           </p:cNvPr>
@@ -5751,7 +6617,7 @@
           <p:cNvPr id="12" name="">
             <a:extLst xmlns:a="http://schemas.openxmlformats.org/drawingml/2006/main">
               <a:ext uri="{FF2B5EF4-FFF2-40B4-BE49-F238E27FC236}">
-                <a16:creationId xmlns:a16="http://schemas.microsoft.com/office/drawing/2014/main" id="{6A67F47D-DE90-4A05-83CD-8CC2B177B9CE}"/>
+                <a16:creationId xmlns:a16="http://schemas.microsoft.com/office/drawing/2014/main" id="{7A740EEE-15FE-49E3-84B2-4426EA709529}"/>
               </a:ext>
             </a:extLst>
           </p:cNvPr>
@@ -5809,7 +6675,7 @@
           <p:cNvPr id="13" name="">
             <a:extLst xmlns:a="http://schemas.openxmlformats.org/drawingml/2006/main">
               <a:ext uri="{FF2B5EF4-FFF2-40B4-BE49-F238E27FC236}">
-                <a16:creationId xmlns:a16="http://schemas.microsoft.com/office/drawing/2014/main" id="{3360DB5B-D5FE-4B75-9EFE-B35DDFD62766}"/>
+                <a16:creationId xmlns:a16="http://schemas.microsoft.com/office/drawing/2014/main" id="{0E28A12C-DC3B-44D9-A316-C71FE3D6B485}"/>
               </a:ext>
             </a:extLst>
           </p:cNvPr>
@@ -5865,7 +6731,7 @@
     </p:spTree>
     <p:extLst>
       <p:ext uri="{BB962C8B-B14F-4D97-AF65-F5344CB8AC3E}">
-        <p14:creationId xmlns:p14="http://schemas.microsoft.com/office/powerpoint/2010/main" val="495213417"/>
+        <p14:creationId xmlns:p14="http://schemas.microsoft.com/office/powerpoint/2010/main" val="825356730"/>
       </p:ext>
     </p:extLst>
   </p:cSld>

</xml_diff>